<commit_message>
portfolio: complete pre-publication QA
</commit_message>
<xml_diff>
--- a/05_pitchbook/MA_Transaction_Pitchbook.pptx
+++ b/05_pitchbook/MA_Transaction_Pitchbook.pptx
@@ -2,25 +2,25 @@
 <file path=ppt/presentation.xml><?xml version="1.0" encoding="utf-8"?>
 <p:presentation xmlns:p="http://schemas.openxmlformats.org/presentationml/2006/main">
   <p:sldMasterIdLst>
-    <p:sldMasterId xmlns:r="http://schemas.openxmlformats.org/officeDocument/2006/relationships" id="2147483648" r:id="R83f74ac3295d40d3"/>
+    <p:sldMasterId xmlns:r="http://schemas.openxmlformats.org/officeDocument/2006/relationships" id="2147483648" r:id="R8df684ea52aa4c07"/>
   </p:sldMasterIdLst>
   <p:notesMasterIdLst>
-    <p:notesMasterId xmlns:r="http://schemas.openxmlformats.org/officeDocument/2006/relationships" r:id="R37dfc2ba7e204b3c"/>
+    <p:notesMasterId xmlns:r="http://schemas.openxmlformats.org/officeDocument/2006/relationships" r:id="Rde4aedaec51a40b7"/>
   </p:notesMasterIdLst>
   <p:sldIdLst>
-    <p:sldId xmlns:r="http://schemas.openxmlformats.org/officeDocument/2006/relationships" id="256" r:id="R88276b774fc94aa8"/>
-    <p:sldId xmlns:r="http://schemas.openxmlformats.org/officeDocument/2006/relationships" id="257" r:id="R24e2fb4574fc43d9"/>
-    <p:sldId xmlns:r="http://schemas.openxmlformats.org/officeDocument/2006/relationships" id="258" r:id="Rfb0ba70478354b9c"/>
-    <p:sldId xmlns:r="http://schemas.openxmlformats.org/officeDocument/2006/relationships" id="259" r:id="R159506bfecef48c1"/>
-    <p:sldId xmlns:r="http://schemas.openxmlformats.org/officeDocument/2006/relationships" id="260" r:id="R9609e6ee5cd04b44"/>
-    <p:sldId xmlns:r="http://schemas.openxmlformats.org/officeDocument/2006/relationships" id="261" r:id="Re4de7907e8f04e0e"/>
-    <p:sldId xmlns:r="http://schemas.openxmlformats.org/officeDocument/2006/relationships" id="262" r:id="R38d86b95bc444dbe"/>
-    <p:sldId xmlns:r="http://schemas.openxmlformats.org/officeDocument/2006/relationships" id="263" r:id="R2e706042cafc485f"/>
-    <p:sldId xmlns:r="http://schemas.openxmlformats.org/officeDocument/2006/relationships" id="264" r:id="Rf0cddb406c06459c"/>
-    <p:sldId xmlns:r="http://schemas.openxmlformats.org/officeDocument/2006/relationships" id="265" r:id="Ra135e77dee0f4acc"/>
-    <p:sldId xmlns:r="http://schemas.openxmlformats.org/officeDocument/2006/relationships" id="266" r:id="Rf986f3db500f41b2"/>
-    <p:sldId xmlns:r="http://schemas.openxmlformats.org/officeDocument/2006/relationships" id="267" r:id="R0114988003ab4481"/>
-    <p:sldId xmlns:r="http://schemas.openxmlformats.org/officeDocument/2006/relationships" id="268" r:id="R6c631a70083f439c"/>
+    <p:sldId xmlns:r="http://schemas.openxmlformats.org/officeDocument/2006/relationships" id="256" r:id="Rbd94f02b281c410f"/>
+    <p:sldId xmlns:r="http://schemas.openxmlformats.org/officeDocument/2006/relationships" id="257" r:id="R08ed75a718f14548"/>
+    <p:sldId xmlns:r="http://schemas.openxmlformats.org/officeDocument/2006/relationships" id="258" r:id="R5273270073824d39"/>
+    <p:sldId xmlns:r="http://schemas.openxmlformats.org/officeDocument/2006/relationships" id="259" r:id="Rb55151dbd97f41e7"/>
+    <p:sldId xmlns:r="http://schemas.openxmlformats.org/officeDocument/2006/relationships" id="260" r:id="R2dd4779fa0684a60"/>
+    <p:sldId xmlns:r="http://schemas.openxmlformats.org/officeDocument/2006/relationships" id="261" r:id="R4d2780a8812e4ad8"/>
+    <p:sldId xmlns:r="http://schemas.openxmlformats.org/officeDocument/2006/relationships" id="262" r:id="R66a24951085d4822"/>
+    <p:sldId xmlns:r="http://schemas.openxmlformats.org/officeDocument/2006/relationships" id="263" r:id="Rdecb8c55ea7d4d97"/>
+    <p:sldId xmlns:r="http://schemas.openxmlformats.org/officeDocument/2006/relationships" id="264" r:id="R3bc16bfc0e64437d"/>
+    <p:sldId xmlns:r="http://schemas.openxmlformats.org/officeDocument/2006/relationships" id="265" r:id="Rfe34a541545d4e5b"/>
+    <p:sldId xmlns:r="http://schemas.openxmlformats.org/officeDocument/2006/relationships" id="266" r:id="R5f45236fe74c4d9e"/>
+    <p:sldId xmlns:r="http://schemas.openxmlformats.org/officeDocument/2006/relationships" id="267" r:id="Rf4e362b9b60c4002"/>
+    <p:sldId xmlns:r="http://schemas.openxmlformats.org/officeDocument/2006/relationships" id="268" r:id="R903c024090434be5"/>
   </p:sldIdLst>
   <p:sldSz cx="12192000" cy="6858000"/>
   <p:notesSz cx="6858000" cy="9144000"/>
@@ -1507,7 +1507,7 @@
   </p:cSld>
   <p:clrMap bg1="lt1" tx1="dk1" bg2="lt2" tx2="dk2" accent1="accent1" accent2="accent2" accent3="accent3" accent4="accent4" accent5="accent5" accent6="accent6" hlink="hlink" folHlink="folHlink"/>
   <p:sldLayoutIdLst>
-    <p:sldLayoutId xmlns:r="http://schemas.openxmlformats.org/officeDocument/2006/relationships" id="2147483649" r:id="R3282ca38e7db4705"/>
+    <p:sldLayoutId xmlns:r="http://schemas.openxmlformats.org/officeDocument/2006/relationships" id="2147483649" r:id="Rb9c162a8e2234278"/>
   </p:sldLayoutIdLst>
   <p:txStyles>
     <p:titleStyle>
@@ -2771,7 +2771,7 @@
           <p:cNvPr id="7" name="">
             <a:extLst xmlns:a="http://schemas.openxmlformats.org/drawingml/2006/main">
               <a:ext uri="{FF2B5EF4-FFF2-40B4-BE49-F238E27FC236}">
-                <a16:creationId xmlns:a16="http://schemas.microsoft.com/office/drawing/2014/main" id="{6049F844-66A2-470C-BD24-CA9D17AAA628}"/>
+                <a16:creationId xmlns:a16="http://schemas.microsoft.com/office/drawing/2014/main" id="{1DD95A0C-4CE9-431B-A8EE-308E66D6E961}"/>
               </a:ext>
             </a:extLst>
           </p:cNvPr>
@@ -2804,7 +2804,7 @@
           <p:cNvPr id="2" name="">
             <a:extLst xmlns:a="http://schemas.openxmlformats.org/drawingml/2006/main">
               <a:ext uri="{FF2B5EF4-FFF2-40B4-BE49-F238E27FC236}">
-                <a16:creationId xmlns:a16="http://schemas.microsoft.com/office/drawing/2014/main" id="{C4EC916A-E69D-4011-A4E2-305CA178F8FA}"/>
+                <a16:creationId xmlns:a16="http://schemas.microsoft.com/office/drawing/2014/main" id="{5F9740F4-C106-40FE-90E7-3A6E538DF7D6}"/>
               </a:ext>
             </a:extLst>
           </p:cNvPr>
@@ -2854,7 +2854,7 @@
           <p:cNvPr id="3" name="">
             <a:extLst xmlns:a="http://schemas.openxmlformats.org/drawingml/2006/main">
               <a:ext uri="{FF2B5EF4-FFF2-40B4-BE49-F238E27FC236}">
-                <a16:creationId xmlns:a16="http://schemas.microsoft.com/office/drawing/2014/main" id="{5B356530-769A-4273-BA32-3881FBBE0D35}"/>
+                <a16:creationId xmlns:a16="http://schemas.microsoft.com/office/drawing/2014/main" id="{B7B9693B-34A6-4E43-943C-91953D11719E}"/>
               </a:ext>
             </a:extLst>
           </p:cNvPr>
@@ -2904,7 +2904,7 @@
           <p:cNvPr id="4" name="">
             <a:extLst xmlns:a="http://schemas.openxmlformats.org/drawingml/2006/main">
               <a:ext uri="{FF2B5EF4-FFF2-40B4-BE49-F238E27FC236}">
-                <a16:creationId xmlns:a16="http://schemas.microsoft.com/office/drawing/2014/main" id="{1D37B681-2223-452B-997F-1BFF6D278BB1}"/>
+                <a16:creationId xmlns:a16="http://schemas.microsoft.com/office/drawing/2014/main" id="{3FFBBB31-1EE4-4578-ABEE-480158D438C3}"/>
               </a:ext>
             </a:extLst>
           </p:cNvPr>
@@ -2954,7 +2954,7 @@
           <p:cNvPr id="5" name="">
             <a:extLst xmlns:a="http://schemas.openxmlformats.org/drawingml/2006/main">
               <a:ext uri="{FF2B5EF4-FFF2-40B4-BE49-F238E27FC236}">
-                <a16:creationId xmlns:a16="http://schemas.microsoft.com/office/drawing/2014/main" id="{D55D39BE-8F0C-48F9-B54C-98853BAD2602}"/>
+                <a16:creationId xmlns:a16="http://schemas.microsoft.com/office/drawing/2014/main" id="{6F5D48DD-43AB-4E07-8591-6AD8B013B7E8}"/>
               </a:ext>
             </a:extLst>
           </p:cNvPr>
@@ -3004,7 +3004,7 @@
           <p:cNvPr id="6" name="">
             <a:extLst xmlns:a="http://schemas.openxmlformats.org/drawingml/2006/main">
               <a:ext uri="{FF2B5EF4-FFF2-40B4-BE49-F238E27FC236}">
-                <a16:creationId xmlns:a16="http://schemas.microsoft.com/office/drawing/2014/main" id="{92D6F304-0594-4DAE-ABF2-A61A69907A1F}"/>
+                <a16:creationId xmlns:a16="http://schemas.microsoft.com/office/drawing/2014/main" id="{F648124D-CB5F-4FBA-BC8C-98D0626FFA3A}"/>
               </a:ext>
             </a:extLst>
           </p:cNvPr>
@@ -3052,7 +3052,7 @@
     </p:spTree>
     <p:extLst>
       <p:ext uri="{BB962C8B-B14F-4D97-AF65-F5344CB8AC3E}">
-        <p14:creationId xmlns:p14="http://schemas.microsoft.com/office/powerpoint/2010/main" val="604423657"/>
+        <p14:creationId xmlns:p14="http://schemas.microsoft.com/office/powerpoint/2010/main" val="1547901760"/>
       </p:ext>
     </p:extLst>
   </p:cSld>
@@ -3083,7 +3083,7 @@
           <p:cNvPr id="19" name="">
             <a:extLst xmlns:a="http://schemas.openxmlformats.org/drawingml/2006/main">
               <a:ext uri="{FF2B5EF4-FFF2-40B4-BE49-F238E27FC236}">
-                <a16:creationId xmlns:a16="http://schemas.microsoft.com/office/drawing/2014/main" id="{F3E73C69-77CB-44A4-AF86-262DF938AF98}"/>
+                <a16:creationId xmlns:a16="http://schemas.microsoft.com/office/drawing/2014/main" id="{D34CF04C-494E-433B-B131-54E83BD06546}"/>
               </a:ext>
             </a:extLst>
           </p:cNvPr>
@@ -3116,7 +3116,7 @@
           <p:cNvPr id="2" name="">
             <a:extLst xmlns:a="http://schemas.openxmlformats.org/drawingml/2006/main">
               <a:ext uri="{FF2B5EF4-FFF2-40B4-BE49-F238E27FC236}">
-                <a16:creationId xmlns:a16="http://schemas.microsoft.com/office/drawing/2014/main" id="{CF51CD82-B236-47B1-ADC7-474DD427A153}"/>
+                <a16:creationId xmlns:a16="http://schemas.microsoft.com/office/drawing/2014/main" id="{73B527FE-4562-4F6E-85EF-8B29EE48082A}"/>
               </a:ext>
             </a:extLst>
           </p:cNvPr>
@@ -3166,7 +3166,7 @@
           <p:cNvPr id="3" name="">
             <a:extLst xmlns:a="http://schemas.openxmlformats.org/drawingml/2006/main">
               <a:ext uri="{FF2B5EF4-FFF2-40B4-BE49-F238E27FC236}">
-                <a16:creationId xmlns:a16="http://schemas.microsoft.com/office/drawing/2014/main" id="{0FF233B2-A80D-4A04-AB6B-BCF8D36C0B0C}"/>
+                <a16:creationId xmlns:a16="http://schemas.microsoft.com/office/drawing/2014/main" id="{F9139AAC-15FF-4B35-BA32-C4B1FBFCE24D}"/>
               </a:ext>
             </a:extLst>
           </p:cNvPr>
@@ -3199,7 +3199,7 @@
           <p:cNvPr id="4" name="">
             <a:extLst xmlns:a="http://schemas.openxmlformats.org/drawingml/2006/main">
               <a:ext uri="{FF2B5EF4-FFF2-40B4-BE49-F238E27FC236}">
-                <a16:creationId xmlns:a16="http://schemas.microsoft.com/office/drawing/2014/main" id="{15361206-D1C1-46C4-BF95-68109D80C10C}"/>
+                <a16:creationId xmlns:a16="http://schemas.microsoft.com/office/drawing/2014/main" id="{691AFC25-B3FB-4C41-A42E-24B9939170DF}"/>
               </a:ext>
             </a:extLst>
           </p:cNvPr>
@@ -3249,7 +3249,7 @@
           <p:cNvPr id="5" name="">
             <a:extLst xmlns:a="http://schemas.openxmlformats.org/drawingml/2006/main">
               <a:ext uri="{FF2B5EF4-FFF2-40B4-BE49-F238E27FC236}">
-                <a16:creationId xmlns:a16="http://schemas.microsoft.com/office/drawing/2014/main" id="{2CF5F3EC-B5A4-4D06-BC1A-B2BE2965B324}"/>
+                <a16:creationId xmlns:a16="http://schemas.microsoft.com/office/drawing/2014/main" id="{9B421296-A4A6-419D-9629-A66A7D4ABE5B}"/>
               </a:ext>
             </a:extLst>
           </p:cNvPr>
@@ -3306,7 +3306,7 @@
         </p:xfrm>
         <a:graphic xmlns:a="http://schemas.openxmlformats.org/drawingml/2006/main">
           <a:graphicData uri="http://schemas.openxmlformats.org/drawingml/2006/chart">
-            <c:chart xmlns:r="http://schemas.openxmlformats.org/officeDocument/2006/relationships" xmlns:c="http://schemas.openxmlformats.org/drawingml/2006/chart" r:id="R50347d48316a4d5c"/>
+            <c:chart xmlns:r="http://schemas.openxmlformats.org/officeDocument/2006/relationships" xmlns:c="http://schemas.openxmlformats.org/drawingml/2006/chart" r:id="R48fbac48fd684694"/>
           </a:graphicData>
         </a:graphic>
       </p:graphicFrame>
@@ -3315,7 +3315,7 @@
           <p:cNvPr id="7" name="">
             <a:extLst xmlns:a="http://schemas.openxmlformats.org/drawingml/2006/main">
               <a:ext uri="{FF2B5EF4-FFF2-40B4-BE49-F238E27FC236}">
-                <a16:creationId xmlns:a16="http://schemas.microsoft.com/office/drawing/2014/main" id="{2CEF6A4C-C2A6-47AC-A427-06D0DF3EB989}"/>
+                <a16:creationId xmlns:a16="http://schemas.microsoft.com/office/drawing/2014/main" id="{F8B87D97-BCEE-4BE2-8248-04633A04734B}"/>
               </a:ext>
             </a:extLst>
           </p:cNvPr>
@@ -3348,7 +3348,7 @@
           <p:cNvPr id="8" name="">
             <a:extLst xmlns:a="http://schemas.openxmlformats.org/drawingml/2006/main">
               <a:ext uri="{FF2B5EF4-FFF2-40B4-BE49-F238E27FC236}">
-                <a16:creationId xmlns:a16="http://schemas.microsoft.com/office/drawing/2014/main" id="{7A6A8419-4053-4B8C-99AD-598C902E6CC1}"/>
+                <a16:creationId xmlns:a16="http://schemas.microsoft.com/office/drawing/2014/main" id="{2D395BB8-3DFA-4531-A127-04EB49644103}"/>
               </a:ext>
             </a:extLst>
           </p:cNvPr>
@@ -3398,7 +3398,7 @@
           <p:cNvPr id="9" name="">
             <a:extLst xmlns:a="http://schemas.openxmlformats.org/drawingml/2006/main">
               <a:ext uri="{FF2B5EF4-FFF2-40B4-BE49-F238E27FC236}">
-                <a16:creationId xmlns:a16="http://schemas.microsoft.com/office/drawing/2014/main" id="{3A709E09-C6A1-4E87-896E-CA35B312DE98}"/>
+                <a16:creationId xmlns:a16="http://schemas.microsoft.com/office/drawing/2014/main" id="{AF6B8E0F-2740-48D2-A7DA-086F6A0B685E}"/>
               </a:ext>
             </a:extLst>
           </p:cNvPr>
@@ -3448,7 +3448,7 @@
           <p:cNvPr id="10" name="">
             <a:extLst xmlns:a="http://schemas.openxmlformats.org/drawingml/2006/main">
               <a:ext uri="{FF2B5EF4-FFF2-40B4-BE49-F238E27FC236}">
-                <a16:creationId xmlns:a16="http://schemas.microsoft.com/office/drawing/2014/main" id="{5A17C55B-E52A-413E-8ACA-5F0116424D3C}"/>
+                <a16:creationId xmlns:a16="http://schemas.microsoft.com/office/drawing/2014/main" id="{9AD7547D-8DD8-4911-A54F-47318A4E202D}"/>
               </a:ext>
             </a:extLst>
           </p:cNvPr>
@@ -3481,7 +3481,7 @@
           <p:cNvPr id="11" name="">
             <a:extLst xmlns:a="http://schemas.openxmlformats.org/drawingml/2006/main">
               <a:ext uri="{FF2B5EF4-FFF2-40B4-BE49-F238E27FC236}">
-                <a16:creationId xmlns:a16="http://schemas.microsoft.com/office/drawing/2014/main" id="{B729F217-6DD2-4810-BAC1-794769ACDC9B}"/>
+                <a16:creationId xmlns:a16="http://schemas.microsoft.com/office/drawing/2014/main" id="{F64A8BD8-A62D-464F-A74C-8CE91C9646C5}"/>
               </a:ext>
             </a:extLst>
           </p:cNvPr>
@@ -3531,7 +3531,7 @@
           <p:cNvPr id="12" name="">
             <a:extLst xmlns:a="http://schemas.openxmlformats.org/drawingml/2006/main">
               <a:ext uri="{FF2B5EF4-FFF2-40B4-BE49-F238E27FC236}">
-                <a16:creationId xmlns:a16="http://schemas.microsoft.com/office/drawing/2014/main" id="{EE4796FC-C17B-478E-82EA-0C601784C0C6}"/>
+                <a16:creationId xmlns:a16="http://schemas.microsoft.com/office/drawing/2014/main" id="{6A6D2CCF-0E7A-455D-824A-099829E6B9C6}"/>
               </a:ext>
             </a:extLst>
           </p:cNvPr>
@@ -3581,7 +3581,7 @@
           <p:cNvPr id="13" name="">
             <a:extLst xmlns:a="http://schemas.openxmlformats.org/drawingml/2006/main">
               <a:ext uri="{FF2B5EF4-FFF2-40B4-BE49-F238E27FC236}">
-                <a16:creationId xmlns:a16="http://schemas.microsoft.com/office/drawing/2014/main" id="{E7DC7FA7-848A-4B80-B9EB-3BE5260C8D86}"/>
+                <a16:creationId xmlns:a16="http://schemas.microsoft.com/office/drawing/2014/main" id="{9C1F6857-732C-4E26-9915-DDAE8B821E00}"/>
               </a:ext>
             </a:extLst>
           </p:cNvPr>
@@ -3614,7 +3614,7 @@
           <p:cNvPr id="14" name="">
             <a:extLst xmlns:a="http://schemas.openxmlformats.org/drawingml/2006/main">
               <a:ext uri="{FF2B5EF4-FFF2-40B4-BE49-F238E27FC236}">
-                <a16:creationId xmlns:a16="http://schemas.microsoft.com/office/drawing/2014/main" id="{3E2408D8-C9A8-4DAB-8E51-457E8FC9C035}"/>
+                <a16:creationId xmlns:a16="http://schemas.microsoft.com/office/drawing/2014/main" id="{3CF3D6FE-2024-456D-8E72-0B079C4844CF}"/>
               </a:ext>
             </a:extLst>
           </p:cNvPr>
@@ -3664,7 +3664,7 @@
           <p:cNvPr id="15" name="">
             <a:extLst xmlns:a="http://schemas.openxmlformats.org/drawingml/2006/main">
               <a:ext uri="{FF2B5EF4-FFF2-40B4-BE49-F238E27FC236}">
-                <a16:creationId xmlns:a16="http://schemas.microsoft.com/office/drawing/2014/main" id="{42D06DB4-0982-400D-A627-0D7B084995D5}"/>
+                <a16:creationId xmlns:a16="http://schemas.microsoft.com/office/drawing/2014/main" id="{004C4753-96DD-4019-BC64-A5D1C81F1A6C}"/>
               </a:ext>
             </a:extLst>
           </p:cNvPr>
@@ -3714,7 +3714,7 @@
           <p:cNvPr id="16" name="">
             <a:extLst xmlns:a="http://schemas.openxmlformats.org/drawingml/2006/main">
               <a:ext uri="{FF2B5EF4-FFF2-40B4-BE49-F238E27FC236}">
-                <a16:creationId xmlns:a16="http://schemas.microsoft.com/office/drawing/2014/main" id="{E3880079-7A78-4F26-BAC6-CD90F7D3219C}"/>
+                <a16:creationId xmlns:a16="http://schemas.microsoft.com/office/drawing/2014/main" id="{3AA6BE54-C679-475F-9F76-B51A2A8C1BA1}"/>
               </a:ext>
             </a:extLst>
           </p:cNvPr>
@@ -3747,7 +3747,7 @@
           <p:cNvPr id="17" name="">
             <a:extLst xmlns:a="http://schemas.openxmlformats.org/drawingml/2006/main">
               <a:ext uri="{FF2B5EF4-FFF2-40B4-BE49-F238E27FC236}">
-                <a16:creationId xmlns:a16="http://schemas.microsoft.com/office/drawing/2014/main" id="{300E8E6E-7B21-4ACD-B32A-D433F230852B}"/>
+                <a16:creationId xmlns:a16="http://schemas.microsoft.com/office/drawing/2014/main" id="{EBF4F1FB-4BF1-456B-AC13-FACD4577BF66}"/>
               </a:ext>
             </a:extLst>
           </p:cNvPr>
@@ -3797,7 +3797,7 @@
           <p:cNvPr id="18" name="">
             <a:extLst xmlns:a="http://schemas.openxmlformats.org/drawingml/2006/main">
               <a:ext uri="{FF2B5EF4-FFF2-40B4-BE49-F238E27FC236}">
-                <a16:creationId xmlns:a16="http://schemas.microsoft.com/office/drawing/2014/main" id="{A2DBB08F-2CFF-4779-95FB-7658D9F3B264}"/>
+                <a16:creationId xmlns:a16="http://schemas.microsoft.com/office/drawing/2014/main" id="{663FBAEA-F799-4F62-88B5-48C55139C7A8}"/>
               </a:ext>
             </a:extLst>
           </p:cNvPr>
@@ -3845,7 +3845,7 @@
     </p:spTree>
     <p:extLst>
       <p:ext uri="{BB962C8B-B14F-4D97-AF65-F5344CB8AC3E}">
-        <p14:creationId xmlns:p14="http://schemas.microsoft.com/office/powerpoint/2010/main" val="352333481"/>
+        <p14:creationId xmlns:p14="http://schemas.microsoft.com/office/powerpoint/2010/main" val="2006377025"/>
       </p:ext>
     </p:extLst>
   </p:cSld>
@@ -3876,7 +3876,7 @@
           <p:cNvPr id="16" name="">
             <a:extLst xmlns:a="http://schemas.openxmlformats.org/drawingml/2006/main">
               <a:ext uri="{FF2B5EF4-FFF2-40B4-BE49-F238E27FC236}">
-                <a16:creationId xmlns:a16="http://schemas.microsoft.com/office/drawing/2014/main" id="{6351F3B7-68C9-44AB-8015-2E1677EBD7CF}"/>
+                <a16:creationId xmlns:a16="http://schemas.microsoft.com/office/drawing/2014/main" id="{CAF9A954-FA38-4512-81C2-46ABA1CDEA8A}"/>
               </a:ext>
             </a:extLst>
           </p:cNvPr>
@@ -3909,7 +3909,7 @@
           <p:cNvPr id="2" name="">
             <a:extLst xmlns:a="http://schemas.openxmlformats.org/drawingml/2006/main">
               <a:ext uri="{FF2B5EF4-FFF2-40B4-BE49-F238E27FC236}">
-                <a16:creationId xmlns:a16="http://schemas.microsoft.com/office/drawing/2014/main" id="{9834E621-4008-4FB5-895B-3E78F741DA1E}"/>
+                <a16:creationId xmlns:a16="http://schemas.microsoft.com/office/drawing/2014/main" id="{F17A51E4-71B5-4748-83A3-D44E280897AF}"/>
               </a:ext>
             </a:extLst>
           </p:cNvPr>
@@ -3959,7 +3959,7 @@
           <p:cNvPr id="3" name="">
             <a:extLst xmlns:a="http://schemas.openxmlformats.org/drawingml/2006/main">
               <a:ext uri="{FF2B5EF4-FFF2-40B4-BE49-F238E27FC236}">
-                <a16:creationId xmlns:a16="http://schemas.microsoft.com/office/drawing/2014/main" id="{31A30975-4150-43AC-8876-AFDEDE6293FF}"/>
+                <a16:creationId xmlns:a16="http://schemas.microsoft.com/office/drawing/2014/main" id="{34441730-6924-48B1-B42B-FC85C4B29991}"/>
               </a:ext>
             </a:extLst>
           </p:cNvPr>
@@ -3992,7 +3992,7 @@
           <p:cNvPr id="4" name="">
             <a:extLst xmlns:a="http://schemas.openxmlformats.org/drawingml/2006/main">
               <a:ext uri="{FF2B5EF4-FFF2-40B4-BE49-F238E27FC236}">
-                <a16:creationId xmlns:a16="http://schemas.microsoft.com/office/drawing/2014/main" id="{77C704DD-0E2B-488C-887F-577C4EF5BA42}"/>
+                <a16:creationId xmlns:a16="http://schemas.microsoft.com/office/drawing/2014/main" id="{50B2B0AC-102F-40A4-864A-4710502338C3}"/>
               </a:ext>
             </a:extLst>
           </p:cNvPr>
@@ -4042,7 +4042,7 @@
           <p:cNvPr id="5" name="">
             <a:extLst xmlns:a="http://schemas.openxmlformats.org/drawingml/2006/main">
               <a:ext uri="{FF2B5EF4-FFF2-40B4-BE49-F238E27FC236}">
-                <a16:creationId xmlns:a16="http://schemas.microsoft.com/office/drawing/2014/main" id="{BEA46D73-5CC4-4E13-BF0F-D95B696AA0E8}"/>
+                <a16:creationId xmlns:a16="http://schemas.microsoft.com/office/drawing/2014/main" id="{7A3F323C-62FF-4560-9D4A-53C1F2E2E2EA}"/>
               </a:ext>
             </a:extLst>
           </p:cNvPr>
@@ -4886,7 +4886,7 @@
           <p:cNvPr id="7" name="">
             <a:extLst xmlns:a="http://schemas.openxmlformats.org/drawingml/2006/main">
               <a:ext uri="{FF2B5EF4-FFF2-40B4-BE49-F238E27FC236}">
-                <a16:creationId xmlns:a16="http://schemas.microsoft.com/office/drawing/2014/main" id="{31DD61A0-0C37-470E-8972-652DFEEADC46}"/>
+                <a16:creationId xmlns:a16="http://schemas.microsoft.com/office/drawing/2014/main" id="{C0D86A25-5E05-40CE-B7A0-FFB4EA67AB0F}"/>
               </a:ext>
             </a:extLst>
           </p:cNvPr>
@@ -4936,7 +4936,7 @@
           <p:cNvPr id="8" name="">
             <a:extLst xmlns:a="http://schemas.openxmlformats.org/drawingml/2006/main">
               <a:ext uri="{FF2B5EF4-FFF2-40B4-BE49-F238E27FC236}">
-                <a16:creationId xmlns:a16="http://schemas.microsoft.com/office/drawing/2014/main" id="{225E8852-B1E1-4669-89D0-02A678D8EDA5}"/>
+                <a16:creationId xmlns:a16="http://schemas.microsoft.com/office/drawing/2014/main" id="{464A1ABE-F571-4A4A-A102-0C1F9B57B664}"/>
               </a:ext>
             </a:extLst>
           </p:cNvPr>
@@ -4986,7 +4986,7 @@
           <p:cNvPr id="9" name="">
             <a:extLst xmlns:a="http://schemas.openxmlformats.org/drawingml/2006/main">
               <a:ext uri="{FF2B5EF4-FFF2-40B4-BE49-F238E27FC236}">
-                <a16:creationId xmlns:a16="http://schemas.microsoft.com/office/drawing/2014/main" id="{CFB25A0D-5FE9-4E2E-8189-3B61DE27E1F9}"/>
+                <a16:creationId xmlns:a16="http://schemas.microsoft.com/office/drawing/2014/main" id="{4E8BB3AA-FECE-4C6F-AFFF-0729C39F82F6}"/>
               </a:ext>
             </a:extLst>
           </p:cNvPr>
@@ -5036,7 +5036,7 @@
           <p:cNvPr id="10" name="">
             <a:extLst xmlns:a="http://schemas.openxmlformats.org/drawingml/2006/main">
               <a:ext uri="{FF2B5EF4-FFF2-40B4-BE49-F238E27FC236}">
-                <a16:creationId xmlns:a16="http://schemas.microsoft.com/office/drawing/2014/main" id="{ED55433B-4283-450A-88F6-20979D7E0DE8}"/>
+                <a16:creationId xmlns:a16="http://schemas.microsoft.com/office/drawing/2014/main" id="{D77BEFFD-97DF-41A5-B1E0-233638E7CD62}"/>
               </a:ext>
             </a:extLst>
           </p:cNvPr>
@@ -5086,7 +5086,7 @@
           <p:cNvPr id="11" name="">
             <a:extLst xmlns:a="http://schemas.openxmlformats.org/drawingml/2006/main">
               <a:ext uri="{FF2B5EF4-FFF2-40B4-BE49-F238E27FC236}">
-                <a16:creationId xmlns:a16="http://schemas.microsoft.com/office/drawing/2014/main" id="{AE85DB15-ACC1-4B0B-8E94-300FA5444C90}"/>
+                <a16:creationId xmlns:a16="http://schemas.microsoft.com/office/drawing/2014/main" id="{272B5A0F-09F1-4009-9E4C-1E7687EF7B03}"/>
               </a:ext>
             </a:extLst>
           </p:cNvPr>
@@ -5136,7 +5136,7 @@
           <p:cNvPr id="12" name="">
             <a:extLst xmlns:a="http://schemas.openxmlformats.org/drawingml/2006/main">
               <a:ext uri="{FF2B5EF4-FFF2-40B4-BE49-F238E27FC236}">
-                <a16:creationId xmlns:a16="http://schemas.microsoft.com/office/drawing/2014/main" id="{B9575A3D-676E-411C-A7C8-9B2F4809979C}"/>
+                <a16:creationId xmlns:a16="http://schemas.microsoft.com/office/drawing/2014/main" id="{3BAD74B8-D35C-4367-9CEF-ECE6324E7162}"/>
               </a:ext>
             </a:extLst>
           </p:cNvPr>
@@ -5186,7 +5186,7 @@
           <p:cNvPr id="13" name="">
             <a:extLst xmlns:a="http://schemas.openxmlformats.org/drawingml/2006/main">
               <a:ext uri="{FF2B5EF4-FFF2-40B4-BE49-F238E27FC236}">
-                <a16:creationId xmlns:a16="http://schemas.microsoft.com/office/drawing/2014/main" id="{D7374061-6299-4F9B-8881-86269168A00D}"/>
+                <a16:creationId xmlns:a16="http://schemas.microsoft.com/office/drawing/2014/main" id="{E5FDDFA2-6CDE-409A-BEF4-22A88C34E8BE}"/>
               </a:ext>
             </a:extLst>
           </p:cNvPr>
@@ -5236,7 +5236,7 @@
           <p:cNvPr id="14" name="">
             <a:extLst xmlns:a="http://schemas.openxmlformats.org/drawingml/2006/main">
               <a:ext uri="{FF2B5EF4-FFF2-40B4-BE49-F238E27FC236}">
-                <a16:creationId xmlns:a16="http://schemas.microsoft.com/office/drawing/2014/main" id="{42D64802-0A8D-4981-80C8-545EC2B83A47}"/>
+                <a16:creationId xmlns:a16="http://schemas.microsoft.com/office/drawing/2014/main" id="{A442514F-B26E-48BF-B763-60194FC2ED8E}"/>
               </a:ext>
             </a:extLst>
           </p:cNvPr>
@@ -5286,7 +5286,7 @@
           <p:cNvPr id="15" name="">
             <a:extLst xmlns:a="http://schemas.openxmlformats.org/drawingml/2006/main">
               <a:ext uri="{FF2B5EF4-FFF2-40B4-BE49-F238E27FC236}">
-                <a16:creationId xmlns:a16="http://schemas.microsoft.com/office/drawing/2014/main" id="{305A8DB4-A832-4C2D-869F-8246DE1B9403}"/>
+                <a16:creationId xmlns:a16="http://schemas.microsoft.com/office/drawing/2014/main" id="{2A261921-DE0D-4F60-9FDE-C99400511409}"/>
               </a:ext>
             </a:extLst>
           </p:cNvPr>
@@ -5334,7 +5334,7 @@
     </p:spTree>
     <p:extLst>
       <p:ext uri="{BB962C8B-B14F-4D97-AF65-F5344CB8AC3E}">
-        <p14:creationId xmlns:p14="http://schemas.microsoft.com/office/powerpoint/2010/main" val="1399580491"/>
+        <p14:creationId xmlns:p14="http://schemas.microsoft.com/office/powerpoint/2010/main" val="1312644751"/>
       </p:ext>
     </p:extLst>
   </p:cSld>
@@ -5365,7 +5365,7 @@
           <p:cNvPr id="9" name="">
             <a:extLst xmlns:a="http://schemas.openxmlformats.org/drawingml/2006/main">
               <a:ext uri="{FF2B5EF4-FFF2-40B4-BE49-F238E27FC236}">
-                <a16:creationId xmlns:a16="http://schemas.microsoft.com/office/drawing/2014/main" id="{4D00BD09-F9A6-4AA6-B2D9-EC1484F21849}"/>
+                <a16:creationId xmlns:a16="http://schemas.microsoft.com/office/drawing/2014/main" id="{27A33B4A-70CE-4CCE-8027-E5B6CD57ADE5}"/>
               </a:ext>
             </a:extLst>
           </p:cNvPr>
@@ -5398,7 +5398,7 @@
           <p:cNvPr id="2" name="">
             <a:extLst xmlns:a="http://schemas.openxmlformats.org/drawingml/2006/main">
               <a:ext uri="{FF2B5EF4-FFF2-40B4-BE49-F238E27FC236}">
-                <a16:creationId xmlns:a16="http://schemas.microsoft.com/office/drawing/2014/main" id="{18B1EDFC-8C6D-4EB8-9CBF-5083D82A7B17}"/>
+                <a16:creationId xmlns:a16="http://schemas.microsoft.com/office/drawing/2014/main" id="{747DDC68-4FFC-49B8-A81B-100889C5D6C3}"/>
               </a:ext>
             </a:extLst>
           </p:cNvPr>
@@ -5448,7 +5448,7 @@
           <p:cNvPr id="3" name="">
             <a:extLst xmlns:a="http://schemas.openxmlformats.org/drawingml/2006/main">
               <a:ext uri="{FF2B5EF4-FFF2-40B4-BE49-F238E27FC236}">
-                <a16:creationId xmlns:a16="http://schemas.microsoft.com/office/drawing/2014/main" id="{FCC94944-9724-4569-8617-C1720B37B47F}"/>
+                <a16:creationId xmlns:a16="http://schemas.microsoft.com/office/drawing/2014/main" id="{05A4D8D9-D1CF-46B8-9AE7-9C485EF4B3D9}"/>
               </a:ext>
             </a:extLst>
           </p:cNvPr>
@@ -5481,7 +5481,7 @@
           <p:cNvPr id="4" name="">
             <a:extLst xmlns:a="http://schemas.openxmlformats.org/drawingml/2006/main">
               <a:ext uri="{FF2B5EF4-FFF2-40B4-BE49-F238E27FC236}">
-                <a16:creationId xmlns:a16="http://schemas.microsoft.com/office/drawing/2014/main" id="{B8377CBE-0A63-46AA-B425-0C0D554CAF83}"/>
+                <a16:creationId xmlns:a16="http://schemas.microsoft.com/office/drawing/2014/main" id="{E399B2D8-CC11-41CD-B0C4-C3318B70BEB3}"/>
               </a:ext>
             </a:extLst>
           </p:cNvPr>
@@ -5531,7 +5531,7 @@
           <p:cNvPr id="5" name="">
             <a:extLst xmlns:a="http://schemas.openxmlformats.org/drawingml/2006/main">
               <a:ext uri="{FF2B5EF4-FFF2-40B4-BE49-F238E27FC236}">
-                <a16:creationId xmlns:a16="http://schemas.microsoft.com/office/drawing/2014/main" id="{C23E3711-CDAA-4564-A80C-4C4C7411B843}"/>
+                <a16:creationId xmlns:a16="http://schemas.microsoft.com/office/drawing/2014/main" id="{1F07415F-4237-49DB-A9AC-C196AA23DF0B}"/>
               </a:ext>
             </a:extLst>
           </p:cNvPr>
@@ -6059,7 +6059,7 @@
           <p:cNvPr id="7" name="">
             <a:extLst xmlns:a="http://schemas.openxmlformats.org/drawingml/2006/main">
               <a:ext uri="{FF2B5EF4-FFF2-40B4-BE49-F238E27FC236}">
-                <a16:creationId xmlns:a16="http://schemas.microsoft.com/office/drawing/2014/main" id="{81A16982-904C-41B7-B402-E14082E806B6}"/>
+                <a16:creationId xmlns:a16="http://schemas.microsoft.com/office/drawing/2014/main" id="{FD95759B-5771-40B2-B54A-1DD8645E0495}"/>
               </a:ext>
             </a:extLst>
           </p:cNvPr>
@@ -6092,7 +6092,7 @@
           <p:cNvPr id="8" name="">
             <a:extLst xmlns:a="http://schemas.openxmlformats.org/drawingml/2006/main">
               <a:ext uri="{FF2B5EF4-FFF2-40B4-BE49-F238E27FC236}">
-                <a16:creationId xmlns:a16="http://schemas.microsoft.com/office/drawing/2014/main" id="{DB701541-3B9C-4005-ADDA-D8B871CE292C}"/>
+                <a16:creationId xmlns:a16="http://schemas.microsoft.com/office/drawing/2014/main" id="{1C54C565-9E1C-4D29-BBCE-2839CA32A875}"/>
               </a:ext>
             </a:extLst>
           </p:cNvPr>
@@ -6140,7 +6140,7 @@
     </p:spTree>
     <p:extLst>
       <p:ext uri="{BB962C8B-B14F-4D97-AF65-F5344CB8AC3E}">
-        <p14:creationId xmlns:p14="http://schemas.microsoft.com/office/powerpoint/2010/main" val="911637216"/>
+        <p14:creationId xmlns:p14="http://schemas.microsoft.com/office/powerpoint/2010/main" val="516354638"/>
       </p:ext>
     </p:extLst>
   </p:cSld>
@@ -6171,7 +6171,7 @@
           <p:cNvPr id="27" name="">
             <a:extLst xmlns:a="http://schemas.openxmlformats.org/drawingml/2006/main">
               <a:ext uri="{FF2B5EF4-FFF2-40B4-BE49-F238E27FC236}">
-                <a16:creationId xmlns:a16="http://schemas.microsoft.com/office/drawing/2014/main" id="{D317BF70-FB3F-4E5C-9277-690D37FF9587}"/>
+                <a16:creationId xmlns:a16="http://schemas.microsoft.com/office/drawing/2014/main" id="{95A056D2-8A1C-4416-82BB-6B3F7CF95097}"/>
               </a:ext>
             </a:extLst>
           </p:cNvPr>
@@ -6204,7 +6204,7 @@
           <p:cNvPr id="2" name="">
             <a:extLst xmlns:a="http://schemas.openxmlformats.org/drawingml/2006/main">
               <a:ext uri="{FF2B5EF4-FFF2-40B4-BE49-F238E27FC236}">
-                <a16:creationId xmlns:a16="http://schemas.microsoft.com/office/drawing/2014/main" id="{C518EE92-3058-445D-95F6-2FD7981DBFEF}"/>
+                <a16:creationId xmlns:a16="http://schemas.microsoft.com/office/drawing/2014/main" id="{0069DC61-4908-4AA0-964E-A53327999DA2}"/>
               </a:ext>
             </a:extLst>
           </p:cNvPr>
@@ -6254,7 +6254,7 @@
           <p:cNvPr id="3" name="">
             <a:extLst xmlns:a="http://schemas.openxmlformats.org/drawingml/2006/main">
               <a:ext uri="{FF2B5EF4-FFF2-40B4-BE49-F238E27FC236}">
-                <a16:creationId xmlns:a16="http://schemas.microsoft.com/office/drawing/2014/main" id="{3A54C35F-04E9-4648-974F-218A1E87BD37}"/>
+                <a16:creationId xmlns:a16="http://schemas.microsoft.com/office/drawing/2014/main" id="{7B252CAE-2939-4C04-8818-6DDFCBC67123}"/>
               </a:ext>
             </a:extLst>
           </p:cNvPr>
@@ -6287,7 +6287,7 @@
           <p:cNvPr id="4" name="">
             <a:extLst xmlns:a="http://schemas.openxmlformats.org/drawingml/2006/main">
               <a:ext uri="{FF2B5EF4-FFF2-40B4-BE49-F238E27FC236}">
-                <a16:creationId xmlns:a16="http://schemas.microsoft.com/office/drawing/2014/main" id="{4F36E418-93CF-4305-9074-9597FBA08D8C}"/>
+                <a16:creationId xmlns:a16="http://schemas.microsoft.com/office/drawing/2014/main" id="{E618165E-5AD6-48C3-98F2-19911E256EFD}"/>
               </a:ext>
             </a:extLst>
           </p:cNvPr>
@@ -6337,7 +6337,7 @@
           <p:cNvPr id="5" name="">
             <a:extLst xmlns:a="http://schemas.openxmlformats.org/drawingml/2006/main">
               <a:ext uri="{FF2B5EF4-FFF2-40B4-BE49-F238E27FC236}">
-                <a16:creationId xmlns:a16="http://schemas.microsoft.com/office/drawing/2014/main" id="{2525E871-E8BA-4C19-A4F5-A438E46B0ED3}"/>
+                <a16:creationId xmlns:a16="http://schemas.microsoft.com/office/drawing/2014/main" id="{49D09F4A-7A7B-4F84-9E41-66101D83D911}"/>
               </a:ext>
             </a:extLst>
           </p:cNvPr>
@@ -6387,7 +6387,7 @@
           <p:cNvPr id="6" name="">
             <a:extLst xmlns:a="http://schemas.openxmlformats.org/drawingml/2006/main">
               <a:ext uri="{FF2B5EF4-FFF2-40B4-BE49-F238E27FC236}">
-                <a16:creationId xmlns:a16="http://schemas.microsoft.com/office/drawing/2014/main" id="{2B4A8B9C-D060-4828-8D3F-0719AC83C2FF}"/>
+                <a16:creationId xmlns:a16="http://schemas.microsoft.com/office/drawing/2014/main" id="{8E0266AE-1D2E-4352-8E14-47CB6B525099}"/>
               </a:ext>
             </a:extLst>
           </p:cNvPr>
@@ -6437,7 +6437,7 @@
           <p:cNvPr id="7" name="">
             <a:extLst xmlns:a="http://schemas.openxmlformats.org/drawingml/2006/main">
               <a:ext uri="{FF2B5EF4-FFF2-40B4-BE49-F238E27FC236}">
-                <a16:creationId xmlns:a16="http://schemas.microsoft.com/office/drawing/2014/main" id="{CF2E8321-0B35-445A-831A-B0880AA5BF87}"/>
+                <a16:creationId xmlns:a16="http://schemas.microsoft.com/office/drawing/2014/main" id="{0F5A7C6A-8659-40BB-BAFE-A24CC934F106}"/>
               </a:ext>
             </a:extLst>
           </p:cNvPr>
@@ -6470,7 +6470,7 @@
           <p:cNvPr id="8" name="">
             <a:extLst xmlns:a="http://schemas.openxmlformats.org/drawingml/2006/main">
               <a:ext uri="{FF2B5EF4-FFF2-40B4-BE49-F238E27FC236}">
-                <a16:creationId xmlns:a16="http://schemas.microsoft.com/office/drawing/2014/main" id="{91A02D64-BCCF-42B2-AE3D-8E5E59CE5EDF}"/>
+                <a16:creationId xmlns:a16="http://schemas.microsoft.com/office/drawing/2014/main" id="{8F90EF97-2A7B-4BCE-8E06-DE718F930C17}"/>
               </a:ext>
             </a:extLst>
           </p:cNvPr>
@@ -6520,7 +6520,7 @@
           <p:cNvPr id="9" name="">
             <a:extLst xmlns:a="http://schemas.openxmlformats.org/drawingml/2006/main">
               <a:ext uri="{FF2B5EF4-FFF2-40B4-BE49-F238E27FC236}">
-                <a16:creationId xmlns:a16="http://schemas.microsoft.com/office/drawing/2014/main" id="{82A6D7A7-EDFA-4FA3-9CC1-7C4585280C22}"/>
+                <a16:creationId xmlns:a16="http://schemas.microsoft.com/office/drawing/2014/main" id="{F099B481-C53E-4C32-8CFC-B1E727DEC861}"/>
               </a:ext>
             </a:extLst>
           </p:cNvPr>
@@ -6570,7 +6570,7 @@
           <p:cNvPr id="10" name="">
             <a:extLst xmlns:a="http://schemas.openxmlformats.org/drawingml/2006/main">
               <a:ext uri="{FF2B5EF4-FFF2-40B4-BE49-F238E27FC236}">
-                <a16:creationId xmlns:a16="http://schemas.microsoft.com/office/drawing/2014/main" id="{2AD5280A-84BF-4891-A92F-4B2B226FE94A}"/>
+                <a16:creationId xmlns:a16="http://schemas.microsoft.com/office/drawing/2014/main" id="{7ECBE833-F223-4ABE-8B99-0AC992C1F25F}"/>
               </a:ext>
             </a:extLst>
           </p:cNvPr>
@@ -6620,7 +6620,7 @@
           <p:cNvPr id="11" name="">
             <a:extLst xmlns:a="http://schemas.openxmlformats.org/drawingml/2006/main">
               <a:ext uri="{FF2B5EF4-FFF2-40B4-BE49-F238E27FC236}">
-                <a16:creationId xmlns:a16="http://schemas.microsoft.com/office/drawing/2014/main" id="{18386B3F-BE3C-4559-9F89-522D1AD48F5D}"/>
+                <a16:creationId xmlns:a16="http://schemas.microsoft.com/office/drawing/2014/main" id="{F1316A49-04A0-480C-8517-3F95D194B28A}"/>
               </a:ext>
             </a:extLst>
           </p:cNvPr>
@@ -6670,7 +6670,7 @@
           <p:cNvPr id="12" name="">
             <a:extLst xmlns:a="http://schemas.openxmlformats.org/drawingml/2006/main">
               <a:ext uri="{FF2B5EF4-FFF2-40B4-BE49-F238E27FC236}">
-                <a16:creationId xmlns:a16="http://schemas.microsoft.com/office/drawing/2014/main" id="{B1AA17CA-2755-4945-B834-2036E136B24A}"/>
+                <a16:creationId xmlns:a16="http://schemas.microsoft.com/office/drawing/2014/main" id="{F576D6F8-D82E-42D1-912B-E912AC5027C2}"/>
               </a:ext>
             </a:extLst>
           </p:cNvPr>
@@ -6720,7 +6720,7 @@
           <p:cNvPr id="13" name="">
             <a:extLst xmlns:a="http://schemas.openxmlformats.org/drawingml/2006/main">
               <a:ext uri="{FF2B5EF4-FFF2-40B4-BE49-F238E27FC236}">
-                <a16:creationId xmlns:a16="http://schemas.microsoft.com/office/drawing/2014/main" id="{DFC9649F-E131-42B4-A8AD-B98246125752}"/>
+                <a16:creationId xmlns:a16="http://schemas.microsoft.com/office/drawing/2014/main" id="{6F130B6E-2AA8-4A7D-9F25-7344850023BB}"/>
               </a:ext>
             </a:extLst>
           </p:cNvPr>
@@ -6770,7 +6770,7 @@
           <p:cNvPr id="14" name="">
             <a:extLst xmlns:a="http://schemas.openxmlformats.org/drawingml/2006/main">
               <a:ext uri="{FF2B5EF4-FFF2-40B4-BE49-F238E27FC236}">
-                <a16:creationId xmlns:a16="http://schemas.microsoft.com/office/drawing/2014/main" id="{AA582396-9D6B-4297-A8C3-4706F5E75C30}"/>
+                <a16:creationId xmlns:a16="http://schemas.microsoft.com/office/drawing/2014/main" id="{5F4D941E-D6C7-4B9A-86B0-EB78E9D1BDB3}"/>
               </a:ext>
             </a:extLst>
           </p:cNvPr>
@@ -6820,7 +6820,7 @@
           <p:cNvPr id="15" name="">
             <a:extLst xmlns:a="http://schemas.openxmlformats.org/drawingml/2006/main">
               <a:ext uri="{FF2B5EF4-FFF2-40B4-BE49-F238E27FC236}">
-                <a16:creationId xmlns:a16="http://schemas.microsoft.com/office/drawing/2014/main" id="{65388654-BC1E-400A-AA56-1EF084A1F52E}"/>
+                <a16:creationId xmlns:a16="http://schemas.microsoft.com/office/drawing/2014/main" id="{23D04087-760C-4D95-A684-C5707E317752}"/>
               </a:ext>
             </a:extLst>
           </p:cNvPr>
@@ -6870,7 +6870,7 @@
           <p:cNvPr id="16" name="">
             <a:extLst xmlns:a="http://schemas.openxmlformats.org/drawingml/2006/main">
               <a:ext uri="{FF2B5EF4-FFF2-40B4-BE49-F238E27FC236}">
-                <a16:creationId xmlns:a16="http://schemas.microsoft.com/office/drawing/2014/main" id="{8CBF18F8-9ECE-4CC0-983E-F82A6B65AAFF}"/>
+                <a16:creationId xmlns:a16="http://schemas.microsoft.com/office/drawing/2014/main" id="{681B6675-2FD5-493F-95F7-65295584771A}"/>
               </a:ext>
             </a:extLst>
           </p:cNvPr>
@@ -6920,7 +6920,7 @@
           <p:cNvPr id="17" name="">
             <a:extLst xmlns:a="http://schemas.openxmlformats.org/drawingml/2006/main">
               <a:ext uri="{FF2B5EF4-FFF2-40B4-BE49-F238E27FC236}">
-                <a16:creationId xmlns:a16="http://schemas.microsoft.com/office/drawing/2014/main" id="{894AB9F3-EA39-4B8E-B37E-7541F9B99DD8}"/>
+                <a16:creationId xmlns:a16="http://schemas.microsoft.com/office/drawing/2014/main" id="{CCCB0735-6BA0-4181-B750-EAF21C3CF38E}"/>
               </a:ext>
             </a:extLst>
           </p:cNvPr>
@@ -6970,7 +6970,7 @@
           <p:cNvPr id="18" name="">
             <a:extLst xmlns:a="http://schemas.openxmlformats.org/drawingml/2006/main">
               <a:ext uri="{FF2B5EF4-FFF2-40B4-BE49-F238E27FC236}">
-                <a16:creationId xmlns:a16="http://schemas.microsoft.com/office/drawing/2014/main" id="{92D7107D-CED0-4FA6-84AE-B2FF9DE76B11}"/>
+                <a16:creationId xmlns:a16="http://schemas.microsoft.com/office/drawing/2014/main" id="{303B21C7-14B1-413C-9329-57C7BB5985DE}"/>
               </a:ext>
             </a:extLst>
           </p:cNvPr>
@@ -7020,7 +7020,7 @@
           <p:cNvPr id="19" name="">
             <a:extLst xmlns:a="http://schemas.openxmlformats.org/drawingml/2006/main">
               <a:ext uri="{FF2B5EF4-FFF2-40B4-BE49-F238E27FC236}">
-                <a16:creationId xmlns:a16="http://schemas.microsoft.com/office/drawing/2014/main" id="{4880604D-E04D-4C5A-B237-7F5B605C36C0}"/>
+                <a16:creationId xmlns:a16="http://schemas.microsoft.com/office/drawing/2014/main" id="{23FA09D9-AD0E-43BB-813F-AFE316D548A0}"/>
               </a:ext>
             </a:extLst>
           </p:cNvPr>
@@ -7070,7 +7070,7 @@
           <p:cNvPr id="20" name="">
             <a:extLst xmlns:a="http://schemas.openxmlformats.org/drawingml/2006/main">
               <a:ext uri="{FF2B5EF4-FFF2-40B4-BE49-F238E27FC236}">
-                <a16:creationId xmlns:a16="http://schemas.microsoft.com/office/drawing/2014/main" id="{583ECAD9-59CF-48DC-9D05-79107AE90E90}"/>
+                <a16:creationId xmlns:a16="http://schemas.microsoft.com/office/drawing/2014/main" id="{E70B9C49-C459-46EC-BDB6-6D8CD21456FF}"/>
               </a:ext>
             </a:extLst>
           </p:cNvPr>
@@ -7120,7 +7120,7 @@
           <p:cNvPr id="21" name="">
             <a:extLst xmlns:a="http://schemas.openxmlformats.org/drawingml/2006/main">
               <a:ext uri="{FF2B5EF4-FFF2-40B4-BE49-F238E27FC236}">
-                <a16:creationId xmlns:a16="http://schemas.microsoft.com/office/drawing/2014/main" id="{107927E7-8097-4DA2-BBEB-531ECAFAA86B}"/>
+                <a16:creationId xmlns:a16="http://schemas.microsoft.com/office/drawing/2014/main" id="{4650BE11-B059-4417-9F52-F7EB216D22F2}"/>
               </a:ext>
             </a:extLst>
           </p:cNvPr>
@@ -7170,7 +7170,7 @@
           <p:cNvPr id="22" name="">
             <a:extLst xmlns:a="http://schemas.openxmlformats.org/drawingml/2006/main">
               <a:ext uri="{FF2B5EF4-FFF2-40B4-BE49-F238E27FC236}">
-                <a16:creationId xmlns:a16="http://schemas.microsoft.com/office/drawing/2014/main" id="{29C3DC6C-729E-4554-B3B4-61DDD17BB19B}"/>
+                <a16:creationId xmlns:a16="http://schemas.microsoft.com/office/drawing/2014/main" id="{B7C34F69-5615-426D-9989-16F4C10DD405}"/>
               </a:ext>
             </a:extLst>
           </p:cNvPr>
@@ -7220,7 +7220,7 @@
           <p:cNvPr id="23" name="">
             <a:extLst xmlns:a="http://schemas.openxmlformats.org/drawingml/2006/main">
               <a:ext uri="{FF2B5EF4-FFF2-40B4-BE49-F238E27FC236}">
-                <a16:creationId xmlns:a16="http://schemas.microsoft.com/office/drawing/2014/main" id="{613FF93E-B5F6-414A-B796-8A32C83D4C20}"/>
+                <a16:creationId xmlns:a16="http://schemas.microsoft.com/office/drawing/2014/main" id="{19B98B65-C278-4E74-80F7-A08C2C8E57D4}"/>
               </a:ext>
             </a:extLst>
           </p:cNvPr>
@@ -7270,7 +7270,7 @@
           <p:cNvPr id="24" name="">
             <a:extLst xmlns:a="http://schemas.openxmlformats.org/drawingml/2006/main">
               <a:ext uri="{FF2B5EF4-FFF2-40B4-BE49-F238E27FC236}">
-                <a16:creationId xmlns:a16="http://schemas.microsoft.com/office/drawing/2014/main" id="{6DCCF35D-66EB-43A4-9D3C-BA7BEDE6E2D3}"/>
+                <a16:creationId xmlns:a16="http://schemas.microsoft.com/office/drawing/2014/main" id="{F4822D20-BE7D-44E0-94D9-B0ABDBBB7E04}"/>
               </a:ext>
             </a:extLst>
           </p:cNvPr>
@@ -7320,7 +7320,7 @@
           <p:cNvPr id="25" name="">
             <a:extLst xmlns:a="http://schemas.openxmlformats.org/drawingml/2006/main">
               <a:ext uri="{FF2B5EF4-FFF2-40B4-BE49-F238E27FC236}">
-                <a16:creationId xmlns:a16="http://schemas.microsoft.com/office/drawing/2014/main" id="{217CE3A0-C7A7-4060-9196-6D7271F0ECDB}"/>
+                <a16:creationId xmlns:a16="http://schemas.microsoft.com/office/drawing/2014/main" id="{B63913C0-9E22-4D5E-9471-249B03490134}"/>
               </a:ext>
             </a:extLst>
           </p:cNvPr>
@@ -7370,7 +7370,7 @@
           <p:cNvPr id="26" name="">
             <a:extLst xmlns:a="http://schemas.openxmlformats.org/drawingml/2006/main">
               <a:ext uri="{FF2B5EF4-FFF2-40B4-BE49-F238E27FC236}">
-                <a16:creationId xmlns:a16="http://schemas.microsoft.com/office/drawing/2014/main" id="{39EE1FDF-0E75-4ABE-8333-858F5419F6E2}"/>
+                <a16:creationId xmlns:a16="http://schemas.microsoft.com/office/drawing/2014/main" id="{431ADE16-B0F9-452E-B838-B797C53BE292}"/>
               </a:ext>
             </a:extLst>
           </p:cNvPr>
@@ -7418,7 +7418,7 @@
     </p:spTree>
     <p:extLst>
       <p:ext uri="{BB962C8B-B14F-4D97-AF65-F5344CB8AC3E}">
-        <p14:creationId xmlns:p14="http://schemas.microsoft.com/office/powerpoint/2010/main" val="890292127"/>
+        <p14:creationId xmlns:p14="http://schemas.microsoft.com/office/powerpoint/2010/main" val="159943346"/>
       </p:ext>
     </p:extLst>
   </p:cSld>
@@ -7449,7 +7449,7 @@
           <p:cNvPr id="30" name="">
             <a:extLst xmlns:a="http://schemas.openxmlformats.org/drawingml/2006/main">
               <a:ext uri="{FF2B5EF4-FFF2-40B4-BE49-F238E27FC236}">
-                <a16:creationId xmlns:a16="http://schemas.microsoft.com/office/drawing/2014/main" id="{AA9F812E-0DE0-4A8B-98DB-237FD7C12A36}"/>
+                <a16:creationId xmlns:a16="http://schemas.microsoft.com/office/drawing/2014/main" id="{BD0D1667-F49E-442E-B8B8-5F18A8551FF3}"/>
               </a:ext>
             </a:extLst>
           </p:cNvPr>
@@ -7482,7 +7482,7 @@
           <p:cNvPr id="2" name="">
             <a:extLst xmlns:a="http://schemas.openxmlformats.org/drawingml/2006/main">
               <a:ext uri="{FF2B5EF4-FFF2-40B4-BE49-F238E27FC236}">
-                <a16:creationId xmlns:a16="http://schemas.microsoft.com/office/drawing/2014/main" id="{B535BB34-90FA-477C-8B49-EC799F172D0F}"/>
+                <a16:creationId xmlns:a16="http://schemas.microsoft.com/office/drawing/2014/main" id="{C9D3C2A9-8B9D-4DF7-BD0D-495B6409A791}"/>
               </a:ext>
             </a:extLst>
           </p:cNvPr>
@@ -7532,7 +7532,7 @@
           <p:cNvPr id="3" name="">
             <a:extLst xmlns:a="http://schemas.openxmlformats.org/drawingml/2006/main">
               <a:ext uri="{FF2B5EF4-FFF2-40B4-BE49-F238E27FC236}">
-                <a16:creationId xmlns:a16="http://schemas.microsoft.com/office/drawing/2014/main" id="{A129A70C-64A9-4C61-8BA2-8AD6AE29DCDF}"/>
+                <a16:creationId xmlns:a16="http://schemas.microsoft.com/office/drawing/2014/main" id="{ED387781-F042-4E80-9798-22E4C8F61B2B}"/>
               </a:ext>
             </a:extLst>
           </p:cNvPr>
@@ -7565,7 +7565,7 @@
           <p:cNvPr id="4" name="">
             <a:extLst xmlns:a="http://schemas.openxmlformats.org/drawingml/2006/main">
               <a:ext uri="{FF2B5EF4-FFF2-40B4-BE49-F238E27FC236}">
-                <a16:creationId xmlns:a16="http://schemas.microsoft.com/office/drawing/2014/main" id="{77003586-B46E-4606-8428-8C6978CCE35F}"/>
+                <a16:creationId xmlns:a16="http://schemas.microsoft.com/office/drawing/2014/main" id="{0ED5360E-9B1C-4EB4-A98F-9A9A4A45FFE9}"/>
               </a:ext>
             </a:extLst>
           </p:cNvPr>
@@ -7615,7 +7615,7 @@
           <p:cNvPr id="5" name="">
             <a:extLst xmlns:a="http://schemas.openxmlformats.org/drawingml/2006/main">
               <a:ext uri="{FF2B5EF4-FFF2-40B4-BE49-F238E27FC236}">
-                <a16:creationId xmlns:a16="http://schemas.microsoft.com/office/drawing/2014/main" id="{CE1B4770-5E40-442A-928B-4604D611F37D}"/>
+                <a16:creationId xmlns:a16="http://schemas.microsoft.com/office/drawing/2014/main" id="{9CE5E1CD-7048-4DEF-9FB0-1CC2E9580A1D}"/>
               </a:ext>
             </a:extLst>
           </p:cNvPr>
@@ -7665,7 +7665,7 @@
           <p:cNvPr id="6" name="">
             <a:extLst xmlns:a="http://schemas.openxmlformats.org/drawingml/2006/main">
               <a:ext uri="{FF2B5EF4-FFF2-40B4-BE49-F238E27FC236}">
-                <a16:creationId xmlns:a16="http://schemas.microsoft.com/office/drawing/2014/main" id="{8E160A47-6DF5-4DF6-8059-9728A763D2FA}"/>
+                <a16:creationId xmlns:a16="http://schemas.microsoft.com/office/drawing/2014/main" id="{A7421032-3CC1-4A14-B4A8-22A59E077EB6}"/>
               </a:ext>
             </a:extLst>
           </p:cNvPr>
@@ -7698,7 +7698,7 @@
           <p:cNvPr id="7" name="">
             <a:extLst xmlns:a="http://schemas.openxmlformats.org/drawingml/2006/main">
               <a:ext uri="{FF2B5EF4-FFF2-40B4-BE49-F238E27FC236}">
-                <a16:creationId xmlns:a16="http://schemas.microsoft.com/office/drawing/2014/main" id="{6CF27443-22D7-4F17-8BA9-C73C1C2A246E}"/>
+                <a16:creationId xmlns:a16="http://schemas.microsoft.com/office/drawing/2014/main" id="{B8ED6774-4055-4FF8-9209-140BD3EBB753}"/>
               </a:ext>
             </a:extLst>
           </p:cNvPr>
@@ -7748,7 +7748,7 @@
           <p:cNvPr id="8" name="">
             <a:extLst xmlns:a="http://schemas.openxmlformats.org/drawingml/2006/main">
               <a:ext uri="{FF2B5EF4-FFF2-40B4-BE49-F238E27FC236}">
-                <a16:creationId xmlns:a16="http://schemas.microsoft.com/office/drawing/2014/main" id="{AE2D21C2-995D-417E-A122-A7F8B40897DA}"/>
+                <a16:creationId xmlns:a16="http://schemas.microsoft.com/office/drawing/2014/main" id="{03A410C5-155B-4D22-9B56-E92EC5880A35}"/>
               </a:ext>
             </a:extLst>
           </p:cNvPr>
@@ -7798,7 +7798,7 @@
           <p:cNvPr id="9" name="">
             <a:extLst xmlns:a="http://schemas.openxmlformats.org/drawingml/2006/main">
               <a:ext uri="{FF2B5EF4-FFF2-40B4-BE49-F238E27FC236}">
-                <a16:creationId xmlns:a16="http://schemas.microsoft.com/office/drawing/2014/main" id="{DCBD47D5-9CC0-4402-9F29-24A598093C73}"/>
+                <a16:creationId xmlns:a16="http://schemas.microsoft.com/office/drawing/2014/main" id="{E0293D31-95F1-4058-AB7C-8E90A822398D}"/>
               </a:ext>
             </a:extLst>
           </p:cNvPr>
@@ -7831,7 +7831,7 @@
           <p:cNvPr id="10" name="">
             <a:extLst xmlns:a="http://schemas.openxmlformats.org/drawingml/2006/main">
               <a:ext uri="{FF2B5EF4-FFF2-40B4-BE49-F238E27FC236}">
-                <a16:creationId xmlns:a16="http://schemas.microsoft.com/office/drawing/2014/main" id="{A33FA8BD-4D55-461F-8F72-4389CBD86FC7}"/>
+                <a16:creationId xmlns:a16="http://schemas.microsoft.com/office/drawing/2014/main" id="{1675D2A4-36A4-4E9C-A1BA-17E5846C9F3C}"/>
               </a:ext>
             </a:extLst>
           </p:cNvPr>
@@ -7881,7 +7881,7 @@
           <p:cNvPr id="11" name="">
             <a:extLst xmlns:a="http://schemas.openxmlformats.org/drawingml/2006/main">
               <a:ext uri="{FF2B5EF4-FFF2-40B4-BE49-F238E27FC236}">
-                <a16:creationId xmlns:a16="http://schemas.microsoft.com/office/drawing/2014/main" id="{325ABA6C-13D4-4231-9F3C-9742317A3AC5}"/>
+                <a16:creationId xmlns:a16="http://schemas.microsoft.com/office/drawing/2014/main" id="{6D6BA6B5-F5A3-4434-98C3-02B6B1FE87B2}"/>
               </a:ext>
             </a:extLst>
           </p:cNvPr>
@@ -7931,7 +7931,7 @@
           <p:cNvPr id="12" name="">
             <a:extLst xmlns:a="http://schemas.openxmlformats.org/drawingml/2006/main">
               <a:ext uri="{FF2B5EF4-FFF2-40B4-BE49-F238E27FC236}">
-                <a16:creationId xmlns:a16="http://schemas.microsoft.com/office/drawing/2014/main" id="{630B8A09-833C-4C16-9429-5CF95C86AC50}"/>
+                <a16:creationId xmlns:a16="http://schemas.microsoft.com/office/drawing/2014/main" id="{C0394ECE-D0EB-4EEF-BB6D-79EF4B05EB72}"/>
               </a:ext>
             </a:extLst>
           </p:cNvPr>
@@ -7964,7 +7964,7 @@
           <p:cNvPr id="13" name="">
             <a:extLst xmlns:a="http://schemas.openxmlformats.org/drawingml/2006/main">
               <a:ext uri="{FF2B5EF4-FFF2-40B4-BE49-F238E27FC236}">
-                <a16:creationId xmlns:a16="http://schemas.microsoft.com/office/drawing/2014/main" id="{B7EDF7D6-68E6-40B0-B574-F2826A82DDB9}"/>
+                <a16:creationId xmlns:a16="http://schemas.microsoft.com/office/drawing/2014/main" id="{3CCE754A-318E-41C8-B703-9BFA65B31CA2}"/>
               </a:ext>
             </a:extLst>
           </p:cNvPr>
@@ -8014,7 +8014,7 @@
           <p:cNvPr id="14" name="">
             <a:extLst xmlns:a="http://schemas.openxmlformats.org/drawingml/2006/main">
               <a:ext uri="{FF2B5EF4-FFF2-40B4-BE49-F238E27FC236}">
-                <a16:creationId xmlns:a16="http://schemas.microsoft.com/office/drawing/2014/main" id="{5078D58B-B15A-4A36-B347-92CB0FC94CC1}"/>
+                <a16:creationId xmlns:a16="http://schemas.microsoft.com/office/drawing/2014/main" id="{9CDBC048-8788-4649-B6E3-923449EF5B99}"/>
               </a:ext>
             </a:extLst>
           </p:cNvPr>
@@ -8064,7 +8064,7 @@
           <p:cNvPr id="15" name="">
             <a:extLst xmlns:a="http://schemas.openxmlformats.org/drawingml/2006/main">
               <a:ext uri="{FF2B5EF4-FFF2-40B4-BE49-F238E27FC236}">
-                <a16:creationId xmlns:a16="http://schemas.microsoft.com/office/drawing/2014/main" id="{161EAF60-14CF-4C1F-857C-2B8DE7260A1F}"/>
+                <a16:creationId xmlns:a16="http://schemas.microsoft.com/office/drawing/2014/main" id="{4C9D215D-730A-40BF-8189-2040414BA78F}"/>
               </a:ext>
             </a:extLst>
           </p:cNvPr>
@@ -8097,7 +8097,7 @@
           <p:cNvPr id="16" name="">
             <a:extLst xmlns:a="http://schemas.openxmlformats.org/drawingml/2006/main">
               <a:ext uri="{FF2B5EF4-FFF2-40B4-BE49-F238E27FC236}">
-                <a16:creationId xmlns:a16="http://schemas.microsoft.com/office/drawing/2014/main" id="{0C840951-DA76-4F93-A5DD-D473DA9F72A0}"/>
+                <a16:creationId xmlns:a16="http://schemas.microsoft.com/office/drawing/2014/main" id="{5F245D86-AA77-4091-AC56-E7760F063140}"/>
               </a:ext>
             </a:extLst>
           </p:cNvPr>
@@ -8147,7 +8147,7 @@
           <p:cNvPr id="17" name="">
             <a:extLst xmlns:a="http://schemas.openxmlformats.org/drawingml/2006/main">
               <a:ext uri="{FF2B5EF4-FFF2-40B4-BE49-F238E27FC236}">
-                <a16:creationId xmlns:a16="http://schemas.microsoft.com/office/drawing/2014/main" id="{0159794F-A3E9-4881-AA8F-E4A77538975D}"/>
+                <a16:creationId xmlns:a16="http://schemas.microsoft.com/office/drawing/2014/main" id="{E9AB0A19-4B9C-4658-B764-A6513884A610}"/>
               </a:ext>
             </a:extLst>
           </p:cNvPr>
@@ -8197,7 +8197,7 @@
           <p:cNvPr id="18" name="">
             <a:extLst xmlns:a="http://schemas.openxmlformats.org/drawingml/2006/main">
               <a:ext uri="{FF2B5EF4-FFF2-40B4-BE49-F238E27FC236}">
-                <a16:creationId xmlns:a16="http://schemas.microsoft.com/office/drawing/2014/main" id="{7A9C26AD-86EC-4B08-8F22-3BC56FD5A55F}"/>
+                <a16:creationId xmlns:a16="http://schemas.microsoft.com/office/drawing/2014/main" id="{6EC9B966-05FD-439E-B4F6-7023D5063DBD}"/>
               </a:ext>
             </a:extLst>
           </p:cNvPr>
@@ -8230,7 +8230,7 @@
           <p:cNvPr id="19" name="">
             <a:extLst xmlns:a="http://schemas.openxmlformats.org/drawingml/2006/main">
               <a:ext uri="{FF2B5EF4-FFF2-40B4-BE49-F238E27FC236}">
-                <a16:creationId xmlns:a16="http://schemas.microsoft.com/office/drawing/2014/main" id="{99EEDDFD-1EAF-4CC7-85AC-3915E7AB4842}"/>
+                <a16:creationId xmlns:a16="http://schemas.microsoft.com/office/drawing/2014/main" id="{FA438D42-5A41-4A7F-BB51-91CA62BE87DD}"/>
               </a:ext>
             </a:extLst>
           </p:cNvPr>
@@ -8280,7 +8280,7 @@
           <p:cNvPr id="20" name="">
             <a:extLst xmlns:a="http://schemas.openxmlformats.org/drawingml/2006/main">
               <a:ext uri="{FF2B5EF4-FFF2-40B4-BE49-F238E27FC236}">
-                <a16:creationId xmlns:a16="http://schemas.microsoft.com/office/drawing/2014/main" id="{2113E744-B7B1-4751-ACCA-8FEA2FCB17B6}"/>
+                <a16:creationId xmlns:a16="http://schemas.microsoft.com/office/drawing/2014/main" id="{578F4A7B-20F5-4224-B681-FC9C9704661A}"/>
               </a:ext>
             </a:extLst>
           </p:cNvPr>
@@ -8330,7 +8330,7 @@
           <p:cNvPr id="21" name="">
             <a:extLst xmlns:a="http://schemas.openxmlformats.org/drawingml/2006/main">
               <a:ext uri="{FF2B5EF4-FFF2-40B4-BE49-F238E27FC236}">
-                <a16:creationId xmlns:a16="http://schemas.microsoft.com/office/drawing/2014/main" id="{682F3931-724F-4F5D-8D2A-B1974994EB3E}"/>
+                <a16:creationId xmlns:a16="http://schemas.microsoft.com/office/drawing/2014/main" id="{0B8A11D5-30A5-4733-A8D9-8184614A77C4}"/>
               </a:ext>
             </a:extLst>
           </p:cNvPr>
@@ -8380,7 +8380,7 @@
           <p:cNvPr id="22" name="">
             <a:extLst xmlns:a="http://schemas.openxmlformats.org/drawingml/2006/main">
               <a:ext uri="{FF2B5EF4-FFF2-40B4-BE49-F238E27FC236}">
-                <a16:creationId xmlns:a16="http://schemas.microsoft.com/office/drawing/2014/main" id="{6706C58F-68FD-4483-BADB-46ABFADC884F}"/>
+                <a16:creationId xmlns:a16="http://schemas.microsoft.com/office/drawing/2014/main" id="{90941784-0CC1-4624-ADBA-2FECE2836DEC}"/>
               </a:ext>
             </a:extLst>
           </p:cNvPr>
@@ -8430,7 +8430,7 @@
           <p:cNvPr id="23" name="">
             <a:extLst xmlns:a="http://schemas.openxmlformats.org/drawingml/2006/main">
               <a:ext uri="{FF2B5EF4-FFF2-40B4-BE49-F238E27FC236}">
-                <a16:creationId xmlns:a16="http://schemas.microsoft.com/office/drawing/2014/main" id="{95CCF4F5-2925-4B45-BAA5-E4BE0FDB2CA9}"/>
+                <a16:creationId xmlns:a16="http://schemas.microsoft.com/office/drawing/2014/main" id="{3B6F5B4D-8355-4066-BF43-3E9721D811F0}"/>
               </a:ext>
             </a:extLst>
           </p:cNvPr>
@@ -8480,7 +8480,7 @@
           <p:cNvPr id="24" name="">
             <a:extLst xmlns:a="http://schemas.openxmlformats.org/drawingml/2006/main">
               <a:ext uri="{FF2B5EF4-FFF2-40B4-BE49-F238E27FC236}">
-                <a16:creationId xmlns:a16="http://schemas.microsoft.com/office/drawing/2014/main" id="{54156B8C-D0A4-48B9-AA42-3CBB4C55D165}"/>
+                <a16:creationId xmlns:a16="http://schemas.microsoft.com/office/drawing/2014/main" id="{8C40AA62-DA4F-4039-BA06-C4A194CE07F7}"/>
               </a:ext>
             </a:extLst>
           </p:cNvPr>
@@ -8530,7 +8530,7 @@
           <p:cNvPr id="25" name="">
             <a:extLst xmlns:a="http://schemas.openxmlformats.org/drawingml/2006/main">
               <a:ext uri="{FF2B5EF4-FFF2-40B4-BE49-F238E27FC236}">
-                <a16:creationId xmlns:a16="http://schemas.microsoft.com/office/drawing/2014/main" id="{206C1040-1FEA-40D2-9B63-DC28FBEE54AD}"/>
+                <a16:creationId xmlns:a16="http://schemas.microsoft.com/office/drawing/2014/main" id="{50D5BD42-AF00-4549-8F9D-CE2477E48917}"/>
               </a:ext>
             </a:extLst>
           </p:cNvPr>
@@ -8580,7 +8580,7 @@
           <p:cNvPr id="26" name="">
             <a:extLst xmlns:a="http://schemas.openxmlformats.org/drawingml/2006/main">
               <a:ext uri="{FF2B5EF4-FFF2-40B4-BE49-F238E27FC236}">
-                <a16:creationId xmlns:a16="http://schemas.microsoft.com/office/drawing/2014/main" id="{2589AC6B-D88D-46A3-9357-D4DFFD770D55}"/>
+                <a16:creationId xmlns:a16="http://schemas.microsoft.com/office/drawing/2014/main" id="{886BBADB-A35F-49A0-8D94-01124A5288BF}"/>
               </a:ext>
             </a:extLst>
           </p:cNvPr>
@@ -8630,7 +8630,7 @@
           <p:cNvPr id="27" name="">
             <a:extLst xmlns:a="http://schemas.openxmlformats.org/drawingml/2006/main">
               <a:ext uri="{FF2B5EF4-FFF2-40B4-BE49-F238E27FC236}">
-                <a16:creationId xmlns:a16="http://schemas.microsoft.com/office/drawing/2014/main" id="{51F79576-6209-4F93-813B-5C8C113EED2A}"/>
+                <a16:creationId xmlns:a16="http://schemas.microsoft.com/office/drawing/2014/main" id="{569C4E1F-2493-4506-A485-F99246D8A1D7}"/>
               </a:ext>
             </a:extLst>
           </p:cNvPr>
@@ -8680,7 +8680,7 @@
           <p:cNvPr id="28" name="">
             <a:extLst xmlns:a="http://schemas.openxmlformats.org/drawingml/2006/main">
               <a:ext uri="{FF2B5EF4-FFF2-40B4-BE49-F238E27FC236}">
-                <a16:creationId xmlns:a16="http://schemas.microsoft.com/office/drawing/2014/main" id="{18AF74F5-31EC-4F84-90B4-482168F555BC}"/>
+                <a16:creationId xmlns:a16="http://schemas.microsoft.com/office/drawing/2014/main" id="{1CB19996-E8B1-4FAD-8D5E-E608EFAA82CB}"/>
               </a:ext>
             </a:extLst>
           </p:cNvPr>
@@ -8730,7 +8730,7 @@
           <p:cNvPr id="29" name="">
             <a:extLst xmlns:a="http://schemas.openxmlformats.org/drawingml/2006/main">
               <a:ext uri="{FF2B5EF4-FFF2-40B4-BE49-F238E27FC236}">
-                <a16:creationId xmlns:a16="http://schemas.microsoft.com/office/drawing/2014/main" id="{C152F3E6-E664-4B90-A316-BE7312F43244}"/>
+                <a16:creationId xmlns:a16="http://schemas.microsoft.com/office/drawing/2014/main" id="{38E29199-6864-4AFA-8A01-96BD34BB7979}"/>
               </a:ext>
             </a:extLst>
           </p:cNvPr>
@@ -8778,7 +8778,7 @@
     </p:spTree>
     <p:extLst>
       <p:ext uri="{BB962C8B-B14F-4D97-AF65-F5344CB8AC3E}">
-        <p14:creationId xmlns:p14="http://schemas.microsoft.com/office/powerpoint/2010/main" val="100131419"/>
+        <p14:creationId xmlns:p14="http://schemas.microsoft.com/office/powerpoint/2010/main" val="1375606613"/>
       </p:ext>
     </p:extLst>
   </p:cSld>
@@ -8809,7 +8809,7 @@
           <p:cNvPr id="26" name="">
             <a:extLst xmlns:a="http://schemas.openxmlformats.org/drawingml/2006/main">
               <a:ext uri="{FF2B5EF4-FFF2-40B4-BE49-F238E27FC236}">
-                <a16:creationId xmlns:a16="http://schemas.microsoft.com/office/drawing/2014/main" id="{C4550768-3B4F-4099-8DF4-AAE3DEBA5C89}"/>
+                <a16:creationId xmlns:a16="http://schemas.microsoft.com/office/drawing/2014/main" id="{81E77144-1978-4AD1-89F6-7C93A8144B38}"/>
               </a:ext>
             </a:extLst>
           </p:cNvPr>
@@ -8842,7 +8842,7 @@
           <p:cNvPr id="2" name="">
             <a:extLst xmlns:a="http://schemas.openxmlformats.org/drawingml/2006/main">
               <a:ext uri="{FF2B5EF4-FFF2-40B4-BE49-F238E27FC236}">
-                <a16:creationId xmlns:a16="http://schemas.microsoft.com/office/drawing/2014/main" id="{274BCFA1-5C79-4CE3-A8AB-E1E3CFBAF037}"/>
+                <a16:creationId xmlns:a16="http://schemas.microsoft.com/office/drawing/2014/main" id="{5CCD2E38-2A7F-49F8-BD4E-92AD1A2B3933}"/>
               </a:ext>
             </a:extLst>
           </p:cNvPr>
@@ -8892,7 +8892,7 @@
           <p:cNvPr id="3" name="">
             <a:extLst xmlns:a="http://schemas.openxmlformats.org/drawingml/2006/main">
               <a:ext uri="{FF2B5EF4-FFF2-40B4-BE49-F238E27FC236}">
-                <a16:creationId xmlns:a16="http://schemas.microsoft.com/office/drawing/2014/main" id="{57ACC169-2E8C-41C0-8FD2-337574469E39}"/>
+                <a16:creationId xmlns:a16="http://schemas.microsoft.com/office/drawing/2014/main" id="{77265E69-DA06-410E-B3B8-4396E1427025}"/>
               </a:ext>
             </a:extLst>
           </p:cNvPr>
@@ -8925,7 +8925,7 @@
           <p:cNvPr id="4" name="">
             <a:extLst xmlns:a="http://schemas.openxmlformats.org/drawingml/2006/main">
               <a:ext uri="{FF2B5EF4-FFF2-40B4-BE49-F238E27FC236}">
-                <a16:creationId xmlns:a16="http://schemas.microsoft.com/office/drawing/2014/main" id="{67F01DBD-DD7F-4D28-A973-9A162B90B8BD}"/>
+                <a16:creationId xmlns:a16="http://schemas.microsoft.com/office/drawing/2014/main" id="{F9EA832A-A4A9-4C7D-B2B7-A3BBC01F2AA9}"/>
               </a:ext>
             </a:extLst>
           </p:cNvPr>
@@ -8975,7 +8975,7 @@
           <p:cNvPr id="5" name="">
             <a:extLst xmlns:a="http://schemas.openxmlformats.org/drawingml/2006/main">
               <a:ext uri="{FF2B5EF4-FFF2-40B4-BE49-F238E27FC236}">
-                <a16:creationId xmlns:a16="http://schemas.microsoft.com/office/drawing/2014/main" id="{5DC051BC-6DBB-4C7F-858B-31512CB45F61}"/>
+                <a16:creationId xmlns:a16="http://schemas.microsoft.com/office/drawing/2014/main" id="{32AB6744-C751-4245-B49E-CBD16ABDD4E8}"/>
               </a:ext>
             </a:extLst>
           </p:cNvPr>
@@ -9025,7 +9025,7 @@
           <p:cNvPr id="6" name="">
             <a:extLst xmlns:a="http://schemas.openxmlformats.org/drawingml/2006/main">
               <a:ext uri="{FF2B5EF4-FFF2-40B4-BE49-F238E27FC236}">
-                <a16:creationId xmlns:a16="http://schemas.microsoft.com/office/drawing/2014/main" id="{E3591E7A-140E-48DA-90C3-BD18F6A97E4D}"/>
+                <a16:creationId xmlns:a16="http://schemas.microsoft.com/office/drawing/2014/main" id="{DC10022E-D535-4ECA-884B-ADE20AF18250}"/>
               </a:ext>
             </a:extLst>
           </p:cNvPr>
@@ -9075,7 +9075,7 @@
           <p:cNvPr id="7" name="">
             <a:extLst xmlns:a="http://schemas.openxmlformats.org/drawingml/2006/main">
               <a:ext uri="{FF2B5EF4-FFF2-40B4-BE49-F238E27FC236}">
-                <a16:creationId xmlns:a16="http://schemas.microsoft.com/office/drawing/2014/main" id="{3E32A55F-3E02-4FE8-AC50-7446073E3373}"/>
+                <a16:creationId xmlns:a16="http://schemas.microsoft.com/office/drawing/2014/main" id="{7F824D35-33D7-48D2-986D-19D6B2F05DFE}"/>
               </a:ext>
             </a:extLst>
           </p:cNvPr>
@@ -9125,7 +9125,7 @@
           <p:cNvPr id="8" name="">
             <a:extLst xmlns:a="http://schemas.openxmlformats.org/drawingml/2006/main">
               <a:ext uri="{FF2B5EF4-FFF2-40B4-BE49-F238E27FC236}">
-                <a16:creationId xmlns:a16="http://schemas.microsoft.com/office/drawing/2014/main" id="{7B559303-856D-4DD4-831B-C3722C9A1729}"/>
+                <a16:creationId xmlns:a16="http://schemas.microsoft.com/office/drawing/2014/main" id="{D8680297-0B3D-455C-948E-B003D613A309}"/>
               </a:ext>
             </a:extLst>
           </p:cNvPr>
@@ -9175,7 +9175,7 @@
           <p:cNvPr id="9" name="">
             <a:extLst xmlns:a="http://schemas.openxmlformats.org/drawingml/2006/main">
               <a:ext uri="{FF2B5EF4-FFF2-40B4-BE49-F238E27FC236}">
-                <a16:creationId xmlns:a16="http://schemas.microsoft.com/office/drawing/2014/main" id="{35FFA02D-6C4F-46BC-BD77-D2E170BE2168}"/>
+                <a16:creationId xmlns:a16="http://schemas.microsoft.com/office/drawing/2014/main" id="{6826C121-AFE9-480F-8C66-342FC1488AE5}"/>
               </a:ext>
             </a:extLst>
           </p:cNvPr>
@@ -9225,7 +9225,7 @@
           <p:cNvPr id="10" name="">
             <a:extLst xmlns:a="http://schemas.openxmlformats.org/drawingml/2006/main">
               <a:ext uri="{FF2B5EF4-FFF2-40B4-BE49-F238E27FC236}">
-                <a16:creationId xmlns:a16="http://schemas.microsoft.com/office/drawing/2014/main" id="{C6067F55-E850-4EE7-AEF8-052FE3D40E10}"/>
+                <a16:creationId xmlns:a16="http://schemas.microsoft.com/office/drawing/2014/main" id="{1D9C60C3-E075-458A-99C0-622B22E42F80}"/>
               </a:ext>
             </a:extLst>
           </p:cNvPr>
@@ -9275,7 +9275,7 @@
           <p:cNvPr id="11" name="">
             <a:extLst xmlns:a="http://schemas.openxmlformats.org/drawingml/2006/main">
               <a:ext uri="{FF2B5EF4-FFF2-40B4-BE49-F238E27FC236}">
-                <a16:creationId xmlns:a16="http://schemas.microsoft.com/office/drawing/2014/main" id="{C5752AAB-33CA-470B-968B-4A18DEC42A6A}"/>
+                <a16:creationId xmlns:a16="http://schemas.microsoft.com/office/drawing/2014/main" id="{4EE6070F-4592-4DCE-99B9-F252D23960B1}"/>
               </a:ext>
             </a:extLst>
           </p:cNvPr>
@@ -9325,7 +9325,7 @@
           <p:cNvPr id="12" name="">
             <a:extLst xmlns:a="http://schemas.openxmlformats.org/drawingml/2006/main">
               <a:ext uri="{FF2B5EF4-FFF2-40B4-BE49-F238E27FC236}">
-                <a16:creationId xmlns:a16="http://schemas.microsoft.com/office/drawing/2014/main" id="{65666D4F-4B5F-4E3C-97D1-9204BA4C8295}"/>
+                <a16:creationId xmlns:a16="http://schemas.microsoft.com/office/drawing/2014/main" id="{23D2C63A-B3F3-4D7B-80FD-0659B5181939}"/>
               </a:ext>
             </a:extLst>
           </p:cNvPr>
@@ -9375,7 +9375,7 @@
           <p:cNvPr id="13" name="">
             <a:extLst xmlns:a="http://schemas.openxmlformats.org/drawingml/2006/main">
               <a:ext uri="{FF2B5EF4-FFF2-40B4-BE49-F238E27FC236}">
-                <a16:creationId xmlns:a16="http://schemas.microsoft.com/office/drawing/2014/main" id="{1C6B86CF-830F-4679-ADDD-7E70C2C8734D}"/>
+                <a16:creationId xmlns:a16="http://schemas.microsoft.com/office/drawing/2014/main" id="{E0E4C505-BF68-4F25-A693-B2A75258314C}"/>
               </a:ext>
             </a:extLst>
           </p:cNvPr>
@@ -9425,7 +9425,7 @@
           <p:cNvPr id="14" name="">
             <a:extLst xmlns:a="http://schemas.openxmlformats.org/drawingml/2006/main">
               <a:ext uri="{FF2B5EF4-FFF2-40B4-BE49-F238E27FC236}">
-                <a16:creationId xmlns:a16="http://schemas.microsoft.com/office/drawing/2014/main" id="{39665CAD-A870-4086-9C8F-B4BB94F2EAC2}"/>
+                <a16:creationId xmlns:a16="http://schemas.microsoft.com/office/drawing/2014/main" id="{9D66E88C-AA9D-45CF-AFEB-B2ED682CE204}"/>
               </a:ext>
             </a:extLst>
           </p:cNvPr>
@@ -9475,7 +9475,7 @@
           <p:cNvPr id="15" name="">
             <a:extLst xmlns:a="http://schemas.openxmlformats.org/drawingml/2006/main">
               <a:ext uri="{FF2B5EF4-FFF2-40B4-BE49-F238E27FC236}">
-                <a16:creationId xmlns:a16="http://schemas.microsoft.com/office/drawing/2014/main" id="{05B8B274-F29C-4359-B341-622EEEE02BC8}"/>
+                <a16:creationId xmlns:a16="http://schemas.microsoft.com/office/drawing/2014/main" id="{F340419A-A2E0-4EAF-9C7A-B19A6A761EDB}"/>
               </a:ext>
             </a:extLst>
           </p:cNvPr>
@@ -9525,7 +9525,7 @@
           <p:cNvPr id="16" name="">
             <a:extLst xmlns:a="http://schemas.openxmlformats.org/drawingml/2006/main">
               <a:ext uri="{FF2B5EF4-FFF2-40B4-BE49-F238E27FC236}">
-                <a16:creationId xmlns:a16="http://schemas.microsoft.com/office/drawing/2014/main" id="{CAE5B8BE-1D9B-4D77-9107-62DE455E5A3C}"/>
+                <a16:creationId xmlns:a16="http://schemas.microsoft.com/office/drawing/2014/main" id="{DFFDF803-B9AA-4D18-A69F-A7D944AD9B7C}"/>
               </a:ext>
             </a:extLst>
           </p:cNvPr>
@@ -9575,7 +9575,7 @@
           <p:cNvPr id="17" name="">
             <a:extLst xmlns:a="http://schemas.openxmlformats.org/drawingml/2006/main">
               <a:ext uri="{FF2B5EF4-FFF2-40B4-BE49-F238E27FC236}">
-                <a16:creationId xmlns:a16="http://schemas.microsoft.com/office/drawing/2014/main" id="{53081754-E99A-43A0-89D8-004FCDD8E33D}"/>
+                <a16:creationId xmlns:a16="http://schemas.microsoft.com/office/drawing/2014/main" id="{615A9F34-81F1-4583-9C57-8B348A5A9E69}"/>
               </a:ext>
             </a:extLst>
           </p:cNvPr>
@@ -9625,7 +9625,7 @@
           <p:cNvPr id="18" name="">
             <a:extLst xmlns:a="http://schemas.openxmlformats.org/drawingml/2006/main">
               <a:ext uri="{FF2B5EF4-FFF2-40B4-BE49-F238E27FC236}">
-                <a16:creationId xmlns:a16="http://schemas.microsoft.com/office/drawing/2014/main" id="{BA01A68D-9F43-424C-956C-99EEF00C0E67}"/>
+                <a16:creationId xmlns:a16="http://schemas.microsoft.com/office/drawing/2014/main" id="{506686DD-5451-4A3C-BE61-36A9728B647B}"/>
               </a:ext>
             </a:extLst>
           </p:cNvPr>
@@ -9675,7 +9675,7 @@
           <p:cNvPr id="19" name="">
             <a:extLst xmlns:a="http://schemas.openxmlformats.org/drawingml/2006/main">
               <a:ext uri="{FF2B5EF4-FFF2-40B4-BE49-F238E27FC236}">
-                <a16:creationId xmlns:a16="http://schemas.microsoft.com/office/drawing/2014/main" id="{5A23A22B-2DAA-4FBD-8E0D-C5CD4E3308B6}"/>
+                <a16:creationId xmlns:a16="http://schemas.microsoft.com/office/drawing/2014/main" id="{4E2D838D-78D9-4F21-88B0-B1B768E2BBB0}"/>
               </a:ext>
             </a:extLst>
           </p:cNvPr>
@@ -9725,7 +9725,7 @@
           <p:cNvPr id="20" name="">
             <a:extLst xmlns:a="http://schemas.openxmlformats.org/drawingml/2006/main">
               <a:ext uri="{FF2B5EF4-FFF2-40B4-BE49-F238E27FC236}">
-                <a16:creationId xmlns:a16="http://schemas.microsoft.com/office/drawing/2014/main" id="{3EFD278B-60DA-41C0-8E0D-6ABEE1C946BD}"/>
+                <a16:creationId xmlns:a16="http://schemas.microsoft.com/office/drawing/2014/main" id="{2C00B86A-17A8-48E3-8C1A-7B8E2C677B97}"/>
               </a:ext>
             </a:extLst>
           </p:cNvPr>
@@ -9775,7 +9775,7 @@
           <p:cNvPr id="21" name="">
             <a:extLst xmlns:a="http://schemas.openxmlformats.org/drawingml/2006/main">
               <a:ext uri="{FF2B5EF4-FFF2-40B4-BE49-F238E27FC236}">
-                <a16:creationId xmlns:a16="http://schemas.microsoft.com/office/drawing/2014/main" id="{63D5DAE9-8075-45EB-A8BE-034907D44C8B}"/>
+                <a16:creationId xmlns:a16="http://schemas.microsoft.com/office/drawing/2014/main" id="{02B400D5-1023-4771-B669-DC9B99C18FEC}"/>
               </a:ext>
             </a:extLst>
           </p:cNvPr>
@@ -9825,7 +9825,7 @@
           <p:cNvPr id="22" name="">
             <a:extLst xmlns:a="http://schemas.openxmlformats.org/drawingml/2006/main">
               <a:ext uri="{FF2B5EF4-FFF2-40B4-BE49-F238E27FC236}">
-                <a16:creationId xmlns:a16="http://schemas.microsoft.com/office/drawing/2014/main" id="{6AE9A94C-11E4-4B4D-88FA-FCC8A61EE997}"/>
+                <a16:creationId xmlns:a16="http://schemas.microsoft.com/office/drawing/2014/main" id="{2BAFCBFE-19E1-4720-8A15-DBD798D6D7C8}"/>
               </a:ext>
             </a:extLst>
           </p:cNvPr>
@@ -9875,7 +9875,7 @@
           <p:cNvPr id="23" name="">
             <a:extLst xmlns:a="http://schemas.openxmlformats.org/drawingml/2006/main">
               <a:ext uri="{FF2B5EF4-FFF2-40B4-BE49-F238E27FC236}">
-                <a16:creationId xmlns:a16="http://schemas.microsoft.com/office/drawing/2014/main" id="{F3423BC1-A759-4FE9-8EB1-71519A14495C}"/>
+                <a16:creationId xmlns:a16="http://schemas.microsoft.com/office/drawing/2014/main" id="{F45F2FA4-4B7F-469B-BAB2-FFCD39D9CA49}"/>
               </a:ext>
             </a:extLst>
           </p:cNvPr>
@@ -9925,7 +9925,7 @@
           <p:cNvPr id="24" name="">
             <a:extLst xmlns:a="http://schemas.openxmlformats.org/drawingml/2006/main">
               <a:ext uri="{FF2B5EF4-FFF2-40B4-BE49-F238E27FC236}">
-                <a16:creationId xmlns:a16="http://schemas.microsoft.com/office/drawing/2014/main" id="{BB72F0F8-BAA6-45D1-9E10-C3D8CBAD8E12}"/>
+                <a16:creationId xmlns:a16="http://schemas.microsoft.com/office/drawing/2014/main" id="{E1B694A2-E3FB-4EA4-8B4F-C95FF1A78B4D}"/>
               </a:ext>
             </a:extLst>
           </p:cNvPr>
@@ -9958,7 +9958,7 @@
           <p:cNvPr id="25" name="">
             <a:extLst xmlns:a="http://schemas.openxmlformats.org/drawingml/2006/main">
               <a:ext uri="{FF2B5EF4-FFF2-40B4-BE49-F238E27FC236}">
-                <a16:creationId xmlns:a16="http://schemas.microsoft.com/office/drawing/2014/main" id="{E979CBEB-F4D7-40B7-AD97-51B02E8D531A}"/>
+                <a16:creationId xmlns:a16="http://schemas.microsoft.com/office/drawing/2014/main" id="{C5620576-99F0-4FA3-9F41-3007E75C901E}"/>
               </a:ext>
             </a:extLst>
           </p:cNvPr>
@@ -10006,7 +10006,7 @@
     </p:spTree>
     <p:extLst>
       <p:ext uri="{BB962C8B-B14F-4D97-AF65-F5344CB8AC3E}">
-        <p14:creationId xmlns:p14="http://schemas.microsoft.com/office/powerpoint/2010/main" val="1181568974"/>
+        <p14:creationId xmlns:p14="http://schemas.microsoft.com/office/powerpoint/2010/main" val="1892766201"/>
       </p:ext>
     </p:extLst>
   </p:cSld>
@@ -10037,7 +10037,7 @@
           <p:cNvPr id="18" name="">
             <a:extLst xmlns:a="http://schemas.openxmlformats.org/drawingml/2006/main">
               <a:ext uri="{FF2B5EF4-FFF2-40B4-BE49-F238E27FC236}">
-                <a16:creationId xmlns:a16="http://schemas.microsoft.com/office/drawing/2014/main" id="{C1737DD7-CDA6-4ADD-BE3D-3EF6459252D9}"/>
+                <a16:creationId xmlns:a16="http://schemas.microsoft.com/office/drawing/2014/main" id="{7BEF252E-D2DF-4C1F-A60C-8FE11B3DD9D2}"/>
               </a:ext>
             </a:extLst>
           </p:cNvPr>
@@ -10070,7 +10070,7 @@
           <p:cNvPr id="2" name="">
             <a:extLst xmlns:a="http://schemas.openxmlformats.org/drawingml/2006/main">
               <a:ext uri="{FF2B5EF4-FFF2-40B4-BE49-F238E27FC236}">
-                <a16:creationId xmlns:a16="http://schemas.microsoft.com/office/drawing/2014/main" id="{0BBD396B-D806-45E3-9115-3C8E95FAF7FB}"/>
+                <a16:creationId xmlns:a16="http://schemas.microsoft.com/office/drawing/2014/main" id="{2858E46E-9906-47F1-8A32-5B8ED510A90F}"/>
               </a:ext>
             </a:extLst>
           </p:cNvPr>
@@ -10120,7 +10120,7 @@
           <p:cNvPr id="3" name="">
             <a:extLst xmlns:a="http://schemas.openxmlformats.org/drawingml/2006/main">
               <a:ext uri="{FF2B5EF4-FFF2-40B4-BE49-F238E27FC236}">
-                <a16:creationId xmlns:a16="http://schemas.microsoft.com/office/drawing/2014/main" id="{66497CE7-A82D-450F-9A71-0C5AFA59A8F3}"/>
+                <a16:creationId xmlns:a16="http://schemas.microsoft.com/office/drawing/2014/main" id="{EA9F5427-BFC9-4C13-919C-C7DAF5F2C0B5}"/>
               </a:ext>
             </a:extLst>
           </p:cNvPr>
@@ -10153,7 +10153,7 @@
           <p:cNvPr id="4" name="">
             <a:extLst xmlns:a="http://schemas.openxmlformats.org/drawingml/2006/main">
               <a:ext uri="{FF2B5EF4-FFF2-40B4-BE49-F238E27FC236}">
-                <a16:creationId xmlns:a16="http://schemas.microsoft.com/office/drawing/2014/main" id="{7EA0F6CD-A4A9-4791-99F2-86CE96CEA436}"/>
+                <a16:creationId xmlns:a16="http://schemas.microsoft.com/office/drawing/2014/main" id="{3AEB0932-1ECD-4F6B-A354-200F34D916F6}"/>
               </a:ext>
             </a:extLst>
           </p:cNvPr>
@@ -10203,7 +10203,7 @@
           <p:cNvPr id="5" name="">
             <a:extLst xmlns:a="http://schemas.openxmlformats.org/drawingml/2006/main">
               <a:ext uri="{FF2B5EF4-FFF2-40B4-BE49-F238E27FC236}">
-                <a16:creationId xmlns:a16="http://schemas.microsoft.com/office/drawing/2014/main" id="{BFE361E9-06A8-49AF-919F-7A6952C4BB0B}"/>
+                <a16:creationId xmlns:a16="http://schemas.microsoft.com/office/drawing/2014/main" id="{E112CB57-1567-4F44-8B19-9892B3FA379C}"/>
               </a:ext>
             </a:extLst>
           </p:cNvPr>
@@ -10260,7 +10260,7 @@
         </p:xfrm>
         <a:graphic xmlns:a="http://schemas.openxmlformats.org/drawingml/2006/main">
           <a:graphicData uri="http://schemas.openxmlformats.org/drawingml/2006/chart">
-            <c:chart xmlns:r="http://schemas.openxmlformats.org/officeDocument/2006/relationships" xmlns:c="http://schemas.openxmlformats.org/drawingml/2006/chart" r:id="Rdeecb8553f0d4bef"/>
+            <c:chart xmlns:r="http://schemas.openxmlformats.org/officeDocument/2006/relationships" xmlns:c="http://schemas.openxmlformats.org/drawingml/2006/chart" r:id="R46ff1aa8a1ca4ce5"/>
           </a:graphicData>
         </a:graphic>
       </p:graphicFrame>
@@ -10269,7 +10269,7 @@
           <p:cNvPr id="7" name="">
             <a:extLst xmlns:a="http://schemas.openxmlformats.org/drawingml/2006/main">
               <a:ext uri="{FF2B5EF4-FFF2-40B4-BE49-F238E27FC236}">
-                <a16:creationId xmlns:a16="http://schemas.microsoft.com/office/drawing/2014/main" id="{6696A245-AF92-465A-B508-692132A57AF5}"/>
+                <a16:creationId xmlns:a16="http://schemas.microsoft.com/office/drawing/2014/main" id="{7DAF1654-6E69-4742-8F83-81ED69D048B8}"/>
               </a:ext>
             </a:extLst>
           </p:cNvPr>
@@ -10319,7 +10319,7 @@
           <p:cNvPr id="8" name="">
             <a:extLst xmlns:a="http://schemas.openxmlformats.org/drawingml/2006/main">
               <a:ext uri="{FF2B5EF4-FFF2-40B4-BE49-F238E27FC236}">
-                <a16:creationId xmlns:a16="http://schemas.microsoft.com/office/drawing/2014/main" id="{FCDF56C1-E693-47B4-9C2A-8DE5BB35B2E1}"/>
+                <a16:creationId xmlns:a16="http://schemas.microsoft.com/office/drawing/2014/main" id="{D52D29C6-69FD-4F2E-9C8A-088800E4761C}"/>
               </a:ext>
             </a:extLst>
           </p:cNvPr>
@@ -10352,7 +10352,7 @@
           <p:cNvPr id="9" name="">
             <a:extLst xmlns:a="http://schemas.openxmlformats.org/drawingml/2006/main">
               <a:ext uri="{FF2B5EF4-FFF2-40B4-BE49-F238E27FC236}">
-                <a16:creationId xmlns:a16="http://schemas.microsoft.com/office/drawing/2014/main" id="{B4DBAD34-C4E7-4B92-B33E-C2BD202C799E}"/>
+                <a16:creationId xmlns:a16="http://schemas.microsoft.com/office/drawing/2014/main" id="{64F45093-85FF-4AAA-9B35-2054CC3210CA}"/>
               </a:ext>
             </a:extLst>
           </p:cNvPr>
@@ -10402,7 +10402,7 @@
           <p:cNvPr id="10" name="">
             <a:extLst xmlns:a="http://schemas.openxmlformats.org/drawingml/2006/main">
               <a:ext uri="{FF2B5EF4-FFF2-40B4-BE49-F238E27FC236}">
-                <a16:creationId xmlns:a16="http://schemas.microsoft.com/office/drawing/2014/main" id="{AC920793-3F3C-48EC-A708-AD76BA28179B}"/>
+                <a16:creationId xmlns:a16="http://schemas.microsoft.com/office/drawing/2014/main" id="{C9C50885-0268-4ECF-915E-FEB73A43026A}"/>
               </a:ext>
             </a:extLst>
           </p:cNvPr>
@@ -10452,7 +10452,7 @@
           <p:cNvPr id="11" name="">
             <a:extLst xmlns:a="http://schemas.openxmlformats.org/drawingml/2006/main">
               <a:ext uri="{FF2B5EF4-FFF2-40B4-BE49-F238E27FC236}">
-                <a16:creationId xmlns:a16="http://schemas.microsoft.com/office/drawing/2014/main" id="{B6804F96-CCE3-45D4-802B-D7641C583339}"/>
+                <a16:creationId xmlns:a16="http://schemas.microsoft.com/office/drawing/2014/main" id="{95B0690F-A1F3-460C-80DB-38B647D37D98}"/>
               </a:ext>
             </a:extLst>
           </p:cNvPr>
@@ -10485,7 +10485,7 @@
           <p:cNvPr id="12" name="">
             <a:extLst xmlns:a="http://schemas.openxmlformats.org/drawingml/2006/main">
               <a:ext uri="{FF2B5EF4-FFF2-40B4-BE49-F238E27FC236}">
-                <a16:creationId xmlns:a16="http://schemas.microsoft.com/office/drawing/2014/main" id="{DE3BC125-DAD9-4370-91FA-EA8A8C81BD60}"/>
+                <a16:creationId xmlns:a16="http://schemas.microsoft.com/office/drawing/2014/main" id="{ACC01C11-FBD7-404D-8E6E-5F55B2079A5A}"/>
               </a:ext>
             </a:extLst>
           </p:cNvPr>
@@ -10535,7 +10535,7 @@
           <p:cNvPr id="13" name="">
             <a:extLst xmlns:a="http://schemas.openxmlformats.org/drawingml/2006/main">
               <a:ext uri="{FF2B5EF4-FFF2-40B4-BE49-F238E27FC236}">
-                <a16:creationId xmlns:a16="http://schemas.microsoft.com/office/drawing/2014/main" id="{D029441B-4FAF-4063-BDC2-83E43CA5FA50}"/>
+                <a16:creationId xmlns:a16="http://schemas.microsoft.com/office/drawing/2014/main" id="{7B466DFD-3A6D-463E-B6A0-D3C6592AE47F}"/>
               </a:ext>
             </a:extLst>
           </p:cNvPr>
@@ -10585,7 +10585,7 @@
           <p:cNvPr id="14" name="">
             <a:extLst xmlns:a="http://schemas.openxmlformats.org/drawingml/2006/main">
               <a:ext uri="{FF2B5EF4-FFF2-40B4-BE49-F238E27FC236}">
-                <a16:creationId xmlns:a16="http://schemas.microsoft.com/office/drawing/2014/main" id="{82A02E08-D480-45DB-83BB-26C0999D72E2}"/>
+                <a16:creationId xmlns:a16="http://schemas.microsoft.com/office/drawing/2014/main" id="{2C1428C4-69C4-4BA5-B944-C710EF8D306D}"/>
               </a:ext>
             </a:extLst>
           </p:cNvPr>
@@ -10618,7 +10618,7 @@
           <p:cNvPr id="15" name="">
             <a:extLst xmlns:a="http://schemas.openxmlformats.org/drawingml/2006/main">
               <a:ext uri="{FF2B5EF4-FFF2-40B4-BE49-F238E27FC236}">
-                <a16:creationId xmlns:a16="http://schemas.microsoft.com/office/drawing/2014/main" id="{FDDA5552-8DB9-4FC2-874D-CE9EE0575CB1}"/>
+                <a16:creationId xmlns:a16="http://schemas.microsoft.com/office/drawing/2014/main" id="{1EC13A10-2615-40CB-8240-222A7F9AE7BD}"/>
               </a:ext>
             </a:extLst>
           </p:cNvPr>
@@ -10668,7 +10668,7 @@
           <p:cNvPr id="16" name="">
             <a:extLst xmlns:a="http://schemas.openxmlformats.org/drawingml/2006/main">
               <a:ext uri="{FF2B5EF4-FFF2-40B4-BE49-F238E27FC236}">
-                <a16:creationId xmlns:a16="http://schemas.microsoft.com/office/drawing/2014/main" id="{B17D7A51-8961-4A43-8987-E16E3AFB1C86}"/>
+                <a16:creationId xmlns:a16="http://schemas.microsoft.com/office/drawing/2014/main" id="{B66175BD-0C33-4134-9A27-5E3BA8929EE0}"/>
               </a:ext>
             </a:extLst>
           </p:cNvPr>
@@ -10718,7 +10718,7 @@
           <p:cNvPr id="17" name="">
             <a:extLst xmlns:a="http://schemas.openxmlformats.org/drawingml/2006/main">
               <a:ext uri="{FF2B5EF4-FFF2-40B4-BE49-F238E27FC236}">
-                <a16:creationId xmlns:a16="http://schemas.microsoft.com/office/drawing/2014/main" id="{56553122-99DA-4074-A219-24715EB94AAA}"/>
+                <a16:creationId xmlns:a16="http://schemas.microsoft.com/office/drawing/2014/main" id="{3864B9BD-2C73-4FC8-974D-D483740367ED}"/>
               </a:ext>
             </a:extLst>
           </p:cNvPr>
@@ -10766,7 +10766,7 @@
     </p:spTree>
     <p:extLst>
       <p:ext uri="{BB962C8B-B14F-4D97-AF65-F5344CB8AC3E}">
-        <p14:creationId xmlns:p14="http://schemas.microsoft.com/office/powerpoint/2010/main" val="117488521"/>
+        <p14:creationId xmlns:p14="http://schemas.microsoft.com/office/powerpoint/2010/main" val="157926224"/>
       </p:ext>
     </p:extLst>
   </p:cSld>
@@ -10797,7 +10797,7 @@
           <p:cNvPr id="17" name="">
             <a:extLst xmlns:a="http://schemas.openxmlformats.org/drawingml/2006/main">
               <a:ext uri="{FF2B5EF4-FFF2-40B4-BE49-F238E27FC236}">
-                <a16:creationId xmlns:a16="http://schemas.microsoft.com/office/drawing/2014/main" id="{7B2869F4-FA91-43D5-9DD5-72C4DC14A40D}"/>
+                <a16:creationId xmlns:a16="http://schemas.microsoft.com/office/drawing/2014/main" id="{1A5743D2-59A9-408B-A3FD-4FA15AD9869C}"/>
               </a:ext>
             </a:extLst>
           </p:cNvPr>
@@ -10830,7 +10830,7 @@
           <p:cNvPr id="2" name="">
             <a:extLst xmlns:a="http://schemas.openxmlformats.org/drawingml/2006/main">
               <a:ext uri="{FF2B5EF4-FFF2-40B4-BE49-F238E27FC236}">
-                <a16:creationId xmlns:a16="http://schemas.microsoft.com/office/drawing/2014/main" id="{CF1DC1C9-A323-4AFB-A1E4-5940D88D1C01}"/>
+                <a16:creationId xmlns:a16="http://schemas.microsoft.com/office/drawing/2014/main" id="{9F7816D9-5413-4260-8F60-7905A0F9D773}"/>
               </a:ext>
             </a:extLst>
           </p:cNvPr>
@@ -10880,7 +10880,7 @@
           <p:cNvPr id="3" name="">
             <a:extLst xmlns:a="http://schemas.openxmlformats.org/drawingml/2006/main">
               <a:ext uri="{FF2B5EF4-FFF2-40B4-BE49-F238E27FC236}">
-                <a16:creationId xmlns:a16="http://schemas.microsoft.com/office/drawing/2014/main" id="{32C7A398-EC41-4691-B8C1-294912EB2916}"/>
+                <a16:creationId xmlns:a16="http://schemas.microsoft.com/office/drawing/2014/main" id="{8F1DAF41-910B-4054-9004-AB131DB72D2A}"/>
               </a:ext>
             </a:extLst>
           </p:cNvPr>
@@ -10913,7 +10913,7 @@
           <p:cNvPr id="4" name="">
             <a:extLst xmlns:a="http://schemas.openxmlformats.org/drawingml/2006/main">
               <a:ext uri="{FF2B5EF4-FFF2-40B4-BE49-F238E27FC236}">
-                <a16:creationId xmlns:a16="http://schemas.microsoft.com/office/drawing/2014/main" id="{2954D548-7493-4A21-BD1E-310E61DE3CA9}"/>
+                <a16:creationId xmlns:a16="http://schemas.microsoft.com/office/drawing/2014/main" id="{11588002-2A4D-468F-B1DC-0143CB76CBCC}"/>
               </a:ext>
             </a:extLst>
           </p:cNvPr>
@@ -10963,7 +10963,7 @@
           <p:cNvPr id="5" name="">
             <a:extLst xmlns:a="http://schemas.openxmlformats.org/drawingml/2006/main">
               <a:ext uri="{FF2B5EF4-FFF2-40B4-BE49-F238E27FC236}">
-                <a16:creationId xmlns:a16="http://schemas.microsoft.com/office/drawing/2014/main" id="{B6E6DA2A-C00A-4D9A-86E8-BBE5D159F0CB}"/>
+                <a16:creationId xmlns:a16="http://schemas.microsoft.com/office/drawing/2014/main" id="{EC852928-F4BB-47B5-A2FE-AE257E978C7F}"/>
               </a:ext>
             </a:extLst>
           </p:cNvPr>
@@ -11639,7 +11639,7 @@
           <p:cNvPr id="7" name="">
             <a:extLst xmlns:a="http://schemas.openxmlformats.org/drawingml/2006/main">
               <a:ext uri="{FF2B5EF4-FFF2-40B4-BE49-F238E27FC236}">
-                <a16:creationId xmlns:a16="http://schemas.microsoft.com/office/drawing/2014/main" id="{40735230-978F-44CE-88C2-F0C4D5DD8398}"/>
+                <a16:creationId xmlns:a16="http://schemas.microsoft.com/office/drawing/2014/main" id="{C743022F-71D0-4824-9EE9-149B6995D46D}"/>
               </a:ext>
             </a:extLst>
           </p:cNvPr>
@@ -11672,7 +11672,7 @@
           <p:cNvPr id="8" name="">
             <a:extLst xmlns:a="http://schemas.openxmlformats.org/drawingml/2006/main">
               <a:ext uri="{FF2B5EF4-FFF2-40B4-BE49-F238E27FC236}">
-                <a16:creationId xmlns:a16="http://schemas.microsoft.com/office/drawing/2014/main" id="{A8E6C7C6-668B-4A22-AA55-166A8CE286DB}"/>
+                <a16:creationId xmlns:a16="http://schemas.microsoft.com/office/drawing/2014/main" id="{4AD7EA50-4FF8-4D1C-B0C4-4230182BE9CB}"/>
               </a:ext>
             </a:extLst>
           </p:cNvPr>
@@ -11722,7 +11722,7 @@
           <p:cNvPr id="9" name="">
             <a:extLst xmlns:a="http://schemas.openxmlformats.org/drawingml/2006/main">
               <a:ext uri="{FF2B5EF4-FFF2-40B4-BE49-F238E27FC236}">
-                <a16:creationId xmlns:a16="http://schemas.microsoft.com/office/drawing/2014/main" id="{48161850-6AA0-4878-8434-5063F18D4475}"/>
+                <a16:creationId xmlns:a16="http://schemas.microsoft.com/office/drawing/2014/main" id="{26961A78-2DBD-45F9-9A87-1BEB45FC3702}"/>
               </a:ext>
             </a:extLst>
           </p:cNvPr>
@@ -11772,7 +11772,7 @@
           <p:cNvPr id="10" name="">
             <a:extLst xmlns:a="http://schemas.openxmlformats.org/drawingml/2006/main">
               <a:ext uri="{FF2B5EF4-FFF2-40B4-BE49-F238E27FC236}">
-                <a16:creationId xmlns:a16="http://schemas.microsoft.com/office/drawing/2014/main" id="{F828922C-B0A6-449A-A98D-9E8352579C48}"/>
+                <a16:creationId xmlns:a16="http://schemas.microsoft.com/office/drawing/2014/main" id="{5CC3E843-EA2B-4316-8BCA-C92C577C15CB}"/>
               </a:ext>
             </a:extLst>
           </p:cNvPr>
@@ -11805,7 +11805,7 @@
           <p:cNvPr id="11" name="">
             <a:extLst xmlns:a="http://schemas.openxmlformats.org/drawingml/2006/main">
               <a:ext uri="{FF2B5EF4-FFF2-40B4-BE49-F238E27FC236}">
-                <a16:creationId xmlns:a16="http://schemas.microsoft.com/office/drawing/2014/main" id="{64729257-4731-4C7A-B25F-77094B0D86A0}"/>
+                <a16:creationId xmlns:a16="http://schemas.microsoft.com/office/drawing/2014/main" id="{95EC0622-35A9-4170-896A-B682471FFF7E}"/>
               </a:ext>
             </a:extLst>
           </p:cNvPr>
@@ -11855,7 +11855,7 @@
           <p:cNvPr id="12" name="">
             <a:extLst xmlns:a="http://schemas.openxmlformats.org/drawingml/2006/main">
               <a:ext uri="{FF2B5EF4-FFF2-40B4-BE49-F238E27FC236}">
-                <a16:creationId xmlns:a16="http://schemas.microsoft.com/office/drawing/2014/main" id="{0DEF8771-1D4D-41D7-A3F8-CCBE57AE515B}"/>
+                <a16:creationId xmlns:a16="http://schemas.microsoft.com/office/drawing/2014/main" id="{B9B6359C-86C3-4B6E-81CD-82E991B894AB}"/>
               </a:ext>
             </a:extLst>
           </p:cNvPr>
@@ -11905,7 +11905,7 @@
           <p:cNvPr id="13" name="">
             <a:extLst xmlns:a="http://schemas.openxmlformats.org/drawingml/2006/main">
               <a:ext uri="{FF2B5EF4-FFF2-40B4-BE49-F238E27FC236}">
-                <a16:creationId xmlns:a16="http://schemas.microsoft.com/office/drawing/2014/main" id="{C77FABD8-40B2-4BEF-9F08-188EECE0EAC1}"/>
+                <a16:creationId xmlns:a16="http://schemas.microsoft.com/office/drawing/2014/main" id="{BBF9E12F-6B4F-417A-AC96-7D34AA15B2DD}"/>
               </a:ext>
             </a:extLst>
           </p:cNvPr>
@@ -11938,7 +11938,7 @@
           <p:cNvPr id="14" name="">
             <a:extLst xmlns:a="http://schemas.openxmlformats.org/drawingml/2006/main">
               <a:ext uri="{FF2B5EF4-FFF2-40B4-BE49-F238E27FC236}">
-                <a16:creationId xmlns:a16="http://schemas.microsoft.com/office/drawing/2014/main" id="{C865A134-A8C5-453A-8BC8-6DDB36A2FE5A}"/>
+                <a16:creationId xmlns:a16="http://schemas.microsoft.com/office/drawing/2014/main" id="{6499AC27-C9C9-4C39-B318-4FEFC38D9085}"/>
               </a:ext>
             </a:extLst>
           </p:cNvPr>
@@ -11988,7 +11988,7 @@
           <p:cNvPr id="15" name="">
             <a:extLst xmlns:a="http://schemas.openxmlformats.org/drawingml/2006/main">
               <a:ext uri="{FF2B5EF4-FFF2-40B4-BE49-F238E27FC236}">
-                <a16:creationId xmlns:a16="http://schemas.microsoft.com/office/drawing/2014/main" id="{9936BD35-19E3-4F0A-84FF-89A634778949}"/>
+                <a16:creationId xmlns:a16="http://schemas.microsoft.com/office/drawing/2014/main" id="{A44D3EC9-51D4-4A35-9A69-BCD6FFE91B46}"/>
               </a:ext>
             </a:extLst>
           </p:cNvPr>
@@ -12038,7 +12038,7 @@
           <p:cNvPr id="16" name="">
             <a:extLst xmlns:a="http://schemas.openxmlformats.org/drawingml/2006/main">
               <a:ext uri="{FF2B5EF4-FFF2-40B4-BE49-F238E27FC236}">
-                <a16:creationId xmlns:a16="http://schemas.microsoft.com/office/drawing/2014/main" id="{2C0C30BB-20D8-48D7-A7D4-D7E206A2B4EC}"/>
+                <a16:creationId xmlns:a16="http://schemas.microsoft.com/office/drawing/2014/main" id="{08F98EDE-4BBE-4931-A7F2-394E8953CBF4}"/>
               </a:ext>
             </a:extLst>
           </p:cNvPr>
@@ -12086,7 +12086,7 @@
     </p:spTree>
     <p:extLst>
       <p:ext uri="{BB962C8B-B14F-4D97-AF65-F5344CB8AC3E}">
-        <p14:creationId xmlns:p14="http://schemas.microsoft.com/office/powerpoint/2010/main" val="119492748"/>
+        <p14:creationId xmlns:p14="http://schemas.microsoft.com/office/powerpoint/2010/main" val="1438762328"/>
       </p:ext>
     </p:extLst>
   </p:cSld>
@@ -12117,7 +12117,7 @@
           <p:cNvPr id="19" name="">
             <a:extLst xmlns:a="http://schemas.openxmlformats.org/drawingml/2006/main">
               <a:ext uri="{FF2B5EF4-FFF2-40B4-BE49-F238E27FC236}">
-                <a16:creationId xmlns:a16="http://schemas.microsoft.com/office/drawing/2014/main" id="{01FBF0D6-1D38-4F92-926B-9F2B2760146B}"/>
+                <a16:creationId xmlns:a16="http://schemas.microsoft.com/office/drawing/2014/main" id="{734BE940-A7B1-4A6D-808C-BFA11B3AFE30}"/>
               </a:ext>
             </a:extLst>
           </p:cNvPr>
@@ -12150,7 +12150,7 @@
           <p:cNvPr id="2" name="">
             <a:extLst xmlns:a="http://schemas.openxmlformats.org/drawingml/2006/main">
               <a:ext uri="{FF2B5EF4-FFF2-40B4-BE49-F238E27FC236}">
-                <a16:creationId xmlns:a16="http://schemas.microsoft.com/office/drawing/2014/main" id="{C528CD40-6C45-4B8B-BA36-59941768F6C0}"/>
+                <a16:creationId xmlns:a16="http://schemas.microsoft.com/office/drawing/2014/main" id="{129DC963-1CCE-46FA-A9A4-C91D856F94FB}"/>
               </a:ext>
             </a:extLst>
           </p:cNvPr>
@@ -12200,7 +12200,7 @@
           <p:cNvPr id="3" name="">
             <a:extLst xmlns:a="http://schemas.openxmlformats.org/drawingml/2006/main">
               <a:ext uri="{FF2B5EF4-FFF2-40B4-BE49-F238E27FC236}">
-                <a16:creationId xmlns:a16="http://schemas.microsoft.com/office/drawing/2014/main" id="{E143A4D5-A1A7-41F2-94F8-2E69737A2FDF}"/>
+                <a16:creationId xmlns:a16="http://schemas.microsoft.com/office/drawing/2014/main" id="{0F1E28A2-F3E9-46D0-99F7-37B9EC57CE11}"/>
               </a:ext>
             </a:extLst>
           </p:cNvPr>
@@ -12233,7 +12233,7 @@
           <p:cNvPr id="4" name="">
             <a:extLst xmlns:a="http://schemas.openxmlformats.org/drawingml/2006/main">
               <a:ext uri="{FF2B5EF4-FFF2-40B4-BE49-F238E27FC236}">
-                <a16:creationId xmlns:a16="http://schemas.microsoft.com/office/drawing/2014/main" id="{36F2F876-D250-429D-9EC6-97FABD180EF4}"/>
+                <a16:creationId xmlns:a16="http://schemas.microsoft.com/office/drawing/2014/main" id="{3D644608-5609-4928-A77F-9007FECE165A}"/>
               </a:ext>
             </a:extLst>
           </p:cNvPr>
@@ -12283,7 +12283,7 @@
           <p:cNvPr id="5" name="">
             <a:extLst xmlns:a="http://schemas.openxmlformats.org/drawingml/2006/main">
               <a:ext uri="{FF2B5EF4-FFF2-40B4-BE49-F238E27FC236}">
-                <a16:creationId xmlns:a16="http://schemas.microsoft.com/office/drawing/2014/main" id="{F635CEF9-70AB-4717-85A9-F8E3D3611646}"/>
+                <a16:creationId xmlns:a16="http://schemas.microsoft.com/office/drawing/2014/main" id="{D5050539-168B-49CA-9A7E-E20FD802FB6E}"/>
               </a:ext>
             </a:extLst>
           </p:cNvPr>
@@ -12333,7 +12333,7 @@
           <p:cNvPr id="6" name="">
             <a:extLst xmlns:a="http://schemas.openxmlformats.org/drawingml/2006/main">
               <a:ext uri="{FF2B5EF4-FFF2-40B4-BE49-F238E27FC236}">
-                <a16:creationId xmlns:a16="http://schemas.microsoft.com/office/drawing/2014/main" id="{65209352-E9DD-4AA4-A87C-B94608D3DDD6}"/>
+                <a16:creationId xmlns:a16="http://schemas.microsoft.com/office/drawing/2014/main" id="{6EDC2B2B-B631-4203-815B-8EDF39F9CDB8}"/>
               </a:ext>
             </a:extLst>
           </p:cNvPr>
@@ -12366,7 +12366,7 @@
           <p:cNvPr id="7" name="">
             <a:extLst xmlns:a="http://schemas.openxmlformats.org/drawingml/2006/main">
               <a:ext uri="{FF2B5EF4-FFF2-40B4-BE49-F238E27FC236}">
-                <a16:creationId xmlns:a16="http://schemas.microsoft.com/office/drawing/2014/main" id="{F5B03AAD-321A-483D-BCE0-936C450A862D}"/>
+                <a16:creationId xmlns:a16="http://schemas.microsoft.com/office/drawing/2014/main" id="{5D2C2550-43B7-4ED3-97CB-0F9A0F60E2AF}"/>
               </a:ext>
             </a:extLst>
           </p:cNvPr>
@@ -12416,7 +12416,7 @@
           <p:cNvPr id="8" name="">
             <a:extLst xmlns:a="http://schemas.openxmlformats.org/drawingml/2006/main">
               <a:ext uri="{FF2B5EF4-FFF2-40B4-BE49-F238E27FC236}">
-                <a16:creationId xmlns:a16="http://schemas.microsoft.com/office/drawing/2014/main" id="{E41B7F41-1595-4EB8-BD1A-678A9BA28560}"/>
+                <a16:creationId xmlns:a16="http://schemas.microsoft.com/office/drawing/2014/main" id="{55D4228D-73D3-4CA2-9800-E77110ED8DA8}"/>
               </a:ext>
             </a:extLst>
           </p:cNvPr>
@@ -12466,7 +12466,7 @@
           <p:cNvPr id="9" name="">
             <a:extLst xmlns:a="http://schemas.openxmlformats.org/drawingml/2006/main">
               <a:ext uri="{FF2B5EF4-FFF2-40B4-BE49-F238E27FC236}">
-                <a16:creationId xmlns:a16="http://schemas.microsoft.com/office/drawing/2014/main" id="{C248F68F-C24C-4BDD-840B-C7D50DEC4603}"/>
+                <a16:creationId xmlns:a16="http://schemas.microsoft.com/office/drawing/2014/main" id="{98F42C87-66A8-4C5D-A01C-5F4CA5A9B1AE}"/>
               </a:ext>
             </a:extLst>
           </p:cNvPr>
@@ -12499,7 +12499,7 @@
           <p:cNvPr id="10" name="">
             <a:extLst xmlns:a="http://schemas.openxmlformats.org/drawingml/2006/main">
               <a:ext uri="{FF2B5EF4-FFF2-40B4-BE49-F238E27FC236}">
-                <a16:creationId xmlns:a16="http://schemas.microsoft.com/office/drawing/2014/main" id="{CD96393A-407E-46E2-826F-6E63CFA9BE02}"/>
+                <a16:creationId xmlns:a16="http://schemas.microsoft.com/office/drawing/2014/main" id="{34FC1C34-17B1-41D4-8554-55E947A456DD}"/>
               </a:ext>
             </a:extLst>
           </p:cNvPr>
@@ -12549,7 +12549,7 @@
           <p:cNvPr id="11" name="">
             <a:extLst xmlns:a="http://schemas.openxmlformats.org/drawingml/2006/main">
               <a:ext uri="{FF2B5EF4-FFF2-40B4-BE49-F238E27FC236}">
-                <a16:creationId xmlns:a16="http://schemas.microsoft.com/office/drawing/2014/main" id="{E1B93344-C850-48BB-B552-7B8841D7EBBD}"/>
+                <a16:creationId xmlns:a16="http://schemas.microsoft.com/office/drawing/2014/main" id="{10B3DA2B-05CE-4BF2-8DFE-5A20E90E9CFB}"/>
               </a:ext>
             </a:extLst>
           </p:cNvPr>
@@ -12599,7 +12599,7 @@
           <p:cNvPr id="12" name="">
             <a:extLst xmlns:a="http://schemas.openxmlformats.org/drawingml/2006/main">
               <a:ext uri="{FF2B5EF4-FFF2-40B4-BE49-F238E27FC236}">
-                <a16:creationId xmlns:a16="http://schemas.microsoft.com/office/drawing/2014/main" id="{ED73F507-23C1-4870-9908-C2CCE453C1CF}"/>
+                <a16:creationId xmlns:a16="http://schemas.microsoft.com/office/drawing/2014/main" id="{C5F1A434-DEC8-4FFA-A21A-58CDC8166D4E}"/>
               </a:ext>
             </a:extLst>
           </p:cNvPr>
@@ -12632,7 +12632,7 @@
           <p:cNvPr id="13" name="">
             <a:extLst xmlns:a="http://schemas.openxmlformats.org/drawingml/2006/main">
               <a:ext uri="{FF2B5EF4-FFF2-40B4-BE49-F238E27FC236}">
-                <a16:creationId xmlns:a16="http://schemas.microsoft.com/office/drawing/2014/main" id="{7281CF98-5BF2-4B76-91A8-BBA1FB018CA3}"/>
+                <a16:creationId xmlns:a16="http://schemas.microsoft.com/office/drawing/2014/main" id="{18E4D50A-101C-4CCE-83F4-6FC72693A2B4}"/>
               </a:ext>
             </a:extLst>
           </p:cNvPr>
@@ -12682,7 +12682,7 @@
           <p:cNvPr id="14" name="">
             <a:extLst xmlns:a="http://schemas.openxmlformats.org/drawingml/2006/main">
               <a:ext uri="{FF2B5EF4-FFF2-40B4-BE49-F238E27FC236}">
-                <a16:creationId xmlns:a16="http://schemas.microsoft.com/office/drawing/2014/main" id="{6EA1E048-64BF-47D0-A8C4-A29E77D4E9C7}"/>
+                <a16:creationId xmlns:a16="http://schemas.microsoft.com/office/drawing/2014/main" id="{81B294C3-53F0-47D1-8CF4-EB4FE98D8DF9}"/>
               </a:ext>
             </a:extLst>
           </p:cNvPr>
@@ -12732,7 +12732,7 @@
           <p:cNvPr id="15" name="">
             <a:extLst xmlns:a="http://schemas.openxmlformats.org/drawingml/2006/main">
               <a:ext uri="{FF2B5EF4-FFF2-40B4-BE49-F238E27FC236}">
-                <a16:creationId xmlns:a16="http://schemas.microsoft.com/office/drawing/2014/main" id="{B788CE51-D868-4FF3-A53F-A997050BA10D}"/>
+                <a16:creationId xmlns:a16="http://schemas.microsoft.com/office/drawing/2014/main" id="{E151D228-4E32-4B12-A60E-73EF4646DBAF}"/>
               </a:ext>
             </a:extLst>
           </p:cNvPr>
@@ -12765,7 +12765,7 @@
           <p:cNvPr id="16" name="">
             <a:extLst xmlns:a="http://schemas.openxmlformats.org/drawingml/2006/main">
               <a:ext uri="{FF2B5EF4-FFF2-40B4-BE49-F238E27FC236}">
-                <a16:creationId xmlns:a16="http://schemas.microsoft.com/office/drawing/2014/main" id="{332E51C2-FC3B-4C5D-9225-7F11E8575BB4}"/>
+                <a16:creationId xmlns:a16="http://schemas.microsoft.com/office/drawing/2014/main" id="{7489FDC8-AB3F-456F-B16C-DD761776EBD6}"/>
               </a:ext>
             </a:extLst>
           </p:cNvPr>
@@ -12815,7 +12815,7 @@
           <p:cNvPr id="17" name="">
             <a:extLst xmlns:a="http://schemas.openxmlformats.org/drawingml/2006/main">
               <a:ext uri="{FF2B5EF4-FFF2-40B4-BE49-F238E27FC236}">
-                <a16:creationId xmlns:a16="http://schemas.microsoft.com/office/drawing/2014/main" id="{1991019B-B85B-4DF6-BA5A-54928DCB74A7}"/>
+                <a16:creationId xmlns:a16="http://schemas.microsoft.com/office/drawing/2014/main" id="{BAE83B01-B2B9-4C6C-B473-90C8ABF5027C}"/>
               </a:ext>
             </a:extLst>
           </p:cNvPr>
@@ -13276,7 +13276,7 @@
     </p:spTree>
     <p:extLst>
       <p:ext uri="{BB962C8B-B14F-4D97-AF65-F5344CB8AC3E}">
-        <p14:creationId xmlns:p14="http://schemas.microsoft.com/office/powerpoint/2010/main" val="795316318"/>
+        <p14:creationId xmlns:p14="http://schemas.microsoft.com/office/powerpoint/2010/main" val="594828543"/>
       </p:ext>
     </p:extLst>
   </p:cSld>
@@ -13307,7 +13307,7 @@
           <p:cNvPr id="10" name="">
             <a:extLst xmlns:a="http://schemas.openxmlformats.org/drawingml/2006/main">
               <a:ext uri="{FF2B5EF4-FFF2-40B4-BE49-F238E27FC236}">
-                <a16:creationId xmlns:a16="http://schemas.microsoft.com/office/drawing/2014/main" id="{621BB309-2935-45E6-9A1E-08FC9A612825}"/>
+                <a16:creationId xmlns:a16="http://schemas.microsoft.com/office/drawing/2014/main" id="{1F6345EB-8B45-472C-AE99-51AE6436479F}"/>
               </a:ext>
             </a:extLst>
           </p:cNvPr>
@@ -13340,7 +13340,7 @@
           <p:cNvPr id="2" name="">
             <a:extLst xmlns:a="http://schemas.openxmlformats.org/drawingml/2006/main">
               <a:ext uri="{FF2B5EF4-FFF2-40B4-BE49-F238E27FC236}">
-                <a16:creationId xmlns:a16="http://schemas.microsoft.com/office/drawing/2014/main" id="{0A9B69E3-E376-43DB-95E0-688B0E6F966F}"/>
+                <a16:creationId xmlns:a16="http://schemas.microsoft.com/office/drawing/2014/main" id="{C90EB7AD-9DE6-4894-BBDC-019E5D6EFCCC}"/>
               </a:ext>
             </a:extLst>
           </p:cNvPr>
@@ -13390,7 +13390,7 @@
           <p:cNvPr id="3" name="">
             <a:extLst xmlns:a="http://schemas.openxmlformats.org/drawingml/2006/main">
               <a:ext uri="{FF2B5EF4-FFF2-40B4-BE49-F238E27FC236}">
-                <a16:creationId xmlns:a16="http://schemas.microsoft.com/office/drawing/2014/main" id="{3E83484E-736F-4225-AEB2-78CECC538D6A}"/>
+                <a16:creationId xmlns:a16="http://schemas.microsoft.com/office/drawing/2014/main" id="{A15F3E5F-981A-47AC-BB07-99D24F7E7170}"/>
               </a:ext>
             </a:extLst>
           </p:cNvPr>
@@ -13423,7 +13423,7 @@
           <p:cNvPr id="4" name="">
             <a:extLst xmlns:a="http://schemas.openxmlformats.org/drawingml/2006/main">
               <a:ext uri="{FF2B5EF4-FFF2-40B4-BE49-F238E27FC236}">
-                <a16:creationId xmlns:a16="http://schemas.microsoft.com/office/drawing/2014/main" id="{002C1709-19A1-4F55-8ABA-1B83EA6E45D3}"/>
+                <a16:creationId xmlns:a16="http://schemas.microsoft.com/office/drawing/2014/main" id="{F168023C-2926-4F57-BB90-71C711C46617}"/>
               </a:ext>
             </a:extLst>
           </p:cNvPr>
@@ -13473,7 +13473,7 @@
           <p:cNvPr id="5" name="">
             <a:extLst xmlns:a="http://schemas.openxmlformats.org/drawingml/2006/main">
               <a:ext uri="{FF2B5EF4-FFF2-40B4-BE49-F238E27FC236}">
-                <a16:creationId xmlns:a16="http://schemas.microsoft.com/office/drawing/2014/main" id="{3D5DF69E-B0EA-4BC6-8180-9191B99134C6}"/>
+                <a16:creationId xmlns:a16="http://schemas.microsoft.com/office/drawing/2014/main" id="{DB68AF5A-AE41-4115-A986-1F2182FBA074}"/>
               </a:ext>
             </a:extLst>
           </p:cNvPr>
@@ -14063,7 +14063,7 @@
           <p:cNvPr id="7" name="">
             <a:extLst xmlns:a="http://schemas.openxmlformats.org/drawingml/2006/main">
               <a:ext uri="{FF2B5EF4-FFF2-40B4-BE49-F238E27FC236}">
-                <a16:creationId xmlns:a16="http://schemas.microsoft.com/office/drawing/2014/main" id="{AE84CFB1-CF5B-4A40-9FEF-CA9D18C08F5D}"/>
+                <a16:creationId xmlns:a16="http://schemas.microsoft.com/office/drawing/2014/main" id="{C5C8B123-E932-434A-9749-852D33FDC940}"/>
               </a:ext>
             </a:extLst>
           </p:cNvPr>
@@ -14096,7 +14096,7 @@
           <p:cNvPr id="8" name="">
             <a:extLst xmlns:a="http://schemas.openxmlformats.org/drawingml/2006/main">
               <a:ext uri="{FF2B5EF4-FFF2-40B4-BE49-F238E27FC236}">
-                <a16:creationId xmlns:a16="http://schemas.microsoft.com/office/drawing/2014/main" id="{68DC8A77-A43C-40C3-AFD6-4606C0310B75}"/>
+                <a16:creationId xmlns:a16="http://schemas.microsoft.com/office/drawing/2014/main" id="{5347D4AB-3AE0-4CE3-9FE5-C3B6071830BB}"/>
               </a:ext>
             </a:extLst>
           </p:cNvPr>
@@ -14146,7 +14146,7 @@
           <p:cNvPr id="9" name="">
             <a:extLst xmlns:a="http://schemas.openxmlformats.org/drawingml/2006/main">
               <a:ext uri="{FF2B5EF4-FFF2-40B4-BE49-F238E27FC236}">
-                <a16:creationId xmlns:a16="http://schemas.microsoft.com/office/drawing/2014/main" id="{BAB0ED8A-7377-4A44-9B35-663BDDA698B1}"/>
+                <a16:creationId xmlns:a16="http://schemas.microsoft.com/office/drawing/2014/main" id="{F0FAD478-3B45-47C9-ACD1-ED94CAD37CD8}"/>
               </a:ext>
             </a:extLst>
           </p:cNvPr>
@@ -14194,7 +14194,7 @@
     </p:spTree>
     <p:extLst>
       <p:ext uri="{BB962C8B-B14F-4D97-AF65-F5344CB8AC3E}">
-        <p14:creationId xmlns:p14="http://schemas.microsoft.com/office/powerpoint/2010/main" val="2145509550"/>
+        <p14:creationId xmlns:p14="http://schemas.microsoft.com/office/powerpoint/2010/main" val="639888288"/>
       </p:ext>
     </p:extLst>
   </p:cSld>
@@ -14225,7 +14225,7 @@
           <p:cNvPr id="25" name="">
             <a:extLst xmlns:a="http://schemas.openxmlformats.org/drawingml/2006/main">
               <a:ext uri="{FF2B5EF4-FFF2-40B4-BE49-F238E27FC236}">
-                <a16:creationId xmlns:a16="http://schemas.microsoft.com/office/drawing/2014/main" id="{AEB2AF4C-DFD0-4906-ACC9-8E059EFBD289}"/>
+                <a16:creationId xmlns:a16="http://schemas.microsoft.com/office/drawing/2014/main" id="{331B4CE2-A145-44DD-BB4B-96AA2A312355}"/>
               </a:ext>
             </a:extLst>
           </p:cNvPr>
@@ -14258,7 +14258,7 @@
           <p:cNvPr id="2" name="">
             <a:extLst xmlns:a="http://schemas.openxmlformats.org/drawingml/2006/main">
               <a:ext uri="{FF2B5EF4-FFF2-40B4-BE49-F238E27FC236}">
-                <a16:creationId xmlns:a16="http://schemas.microsoft.com/office/drawing/2014/main" id="{DB1A6564-E861-4ED6-919B-58A08E4B242F}"/>
+                <a16:creationId xmlns:a16="http://schemas.microsoft.com/office/drawing/2014/main" id="{43F0210A-56FA-4FD3-BA86-AA2EE83C49B5}"/>
               </a:ext>
             </a:extLst>
           </p:cNvPr>
@@ -14308,7 +14308,7 @@
           <p:cNvPr id="3" name="">
             <a:extLst xmlns:a="http://schemas.openxmlformats.org/drawingml/2006/main">
               <a:ext uri="{FF2B5EF4-FFF2-40B4-BE49-F238E27FC236}">
-                <a16:creationId xmlns:a16="http://schemas.microsoft.com/office/drawing/2014/main" id="{0C03BF9A-B075-41DB-AF18-3B770E617136}"/>
+                <a16:creationId xmlns:a16="http://schemas.microsoft.com/office/drawing/2014/main" id="{770B78E8-8A99-4024-937E-45CFD122C615}"/>
               </a:ext>
             </a:extLst>
           </p:cNvPr>
@@ -14341,7 +14341,7 @@
           <p:cNvPr id="4" name="">
             <a:extLst xmlns:a="http://schemas.openxmlformats.org/drawingml/2006/main">
               <a:ext uri="{FF2B5EF4-FFF2-40B4-BE49-F238E27FC236}">
-                <a16:creationId xmlns:a16="http://schemas.microsoft.com/office/drawing/2014/main" id="{5DF72E73-9565-4E50-94A4-601BE2289BCE}"/>
+                <a16:creationId xmlns:a16="http://schemas.microsoft.com/office/drawing/2014/main" id="{1B856AA4-E592-4B7C-AFBC-8100411E7692}"/>
               </a:ext>
             </a:extLst>
           </p:cNvPr>
@@ -14391,7 +14391,7 @@
           <p:cNvPr id="5" name="">
             <a:extLst xmlns:a="http://schemas.openxmlformats.org/drawingml/2006/main">
               <a:ext uri="{FF2B5EF4-FFF2-40B4-BE49-F238E27FC236}">
-                <a16:creationId xmlns:a16="http://schemas.microsoft.com/office/drawing/2014/main" id="{51A4BC90-D128-436A-92D8-05E74DB9EBDB}"/>
+                <a16:creationId xmlns:a16="http://schemas.microsoft.com/office/drawing/2014/main" id="{AAD3EA5B-5FBD-470B-8C87-4921F3861F1D}"/>
               </a:ext>
             </a:extLst>
           </p:cNvPr>
@@ -14448,7 +14448,7 @@
         </p:xfrm>
         <a:graphic xmlns:a="http://schemas.openxmlformats.org/drawingml/2006/main">
           <a:graphicData uri="http://schemas.openxmlformats.org/drawingml/2006/chart">
-            <c:chart xmlns:r="http://schemas.openxmlformats.org/officeDocument/2006/relationships" xmlns:c="http://schemas.openxmlformats.org/drawingml/2006/chart" r:id="Red3bba2f470c477f"/>
+            <c:chart xmlns:r="http://schemas.openxmlformats.org/officeDocument/2006/relationships" xmlns:c="http://schemas.openxmlformats.org/drawingml/2006/chart" r:id="Rfcc965abc2624a2d"/>
           </a:graphicData>
         </a:graphic>
       </p:graphicFrame>
@@ -14457,7 +14457,7 @@
           <p:cNvPr id="7" name="">
             <a:extLst xmlns:a="http://schemas.openxmlformats.org/drawingml/2006/main">
               <a:ext uri="{FF2B5EF4-FFF2-40B4-BE49-F238E27FC236}">
-                <a16:creationId xmlns:a16="http://schemas.microsoft.com/office/drawing/2014/main" id="{65BDE37B-E1E1-482C-8BFE-8AD60747D6E6}"/>
+                <a16:creationId xmlns:a16="http://schemas.microsoft.com/office/drawing/2014/main" id="{33E16F02-BC7E-4728-86CE-8869576FA24A}"/>
               </a:ext>
             </a:extLst>
           </p:cNvPr>
@@ -14490,7 +14490,7 @@
           <p:cNvPr id="8" name="">
             <a:extLst xmlns:a="http://schemas.openxmlformats.org/drawingml/2006/main">
               <a:ext uri="{FF2B5EF4-FFF2-40B4-BE49-F238E27FC236}">
-                <a16:creationId xmlns:a16="http://schemas.microsoft.com/office/drawing/2014/main" id="{0C178907-1760-4788-B929-0CB1E3967E57}"/>
+                <a16:creationId xmlns:a16="http://schemas.microsoft.com/office/drawing/2014/main" id="{012FBA05-16A4-4746-8C3A-DBC8711E8CE3}"/>
               </a:ext>
             </a:extLst>
           </p:cNvPr>
@@ -14540,7 +14540,7 @@
           <p:cNvPr id="9" name="">
             <a:extLst xmlns:a="http://schemas.openxmlformats.org/drawingml/2006/main">
               <a:ext uri="{FF2B5EF4-FFF2-40B4-BE49-F238E27FC236}">
-                <a16:creationId xmlns:a16="http://schemas.microsoft.com/office/drawing/2014/main" id="{478FAC0C-D668-4C0B-B926-AEDB938B1B16}"/>
+                <a16:creationId xmlns:a16="http://schemas.microsoft.com/office/drawing/2014/main" id="{3CAD7A35-947F-440E-AB9C-D93C3F4581F3}"/>
               </a:ext>
             </a:extLst>
           </p:cNvPr>
@@ -14590,7 +14590,7 @@
           <p:cNvPr id="10" name="">
             <a:extLst xmlns:a="http://schemas.openxmlformats.org/drawingml/2006/main">
               <a:ext uri="{FF2B5EF4-FFF2-40B4-BE49-F238E27FC236}">
-                <a16:creationId xmlns:a16="http://schemas.microsoft.com/office/drawing/2014/main" id="{BD893807-9FF6-456B-99CA-814D603685A1}"/>
+                <a16:creationId xmlns:a16="http://schemas.microsoft.com/office/drawing/2014/main" id="{63F82608-5522-4417-BEFD-41972E2D684A}"/>
               </a:ext>
             </a:extLst>
           </p:cNvPr>
@@ -14623,7 +14623,7 @@
           <p:cNvPr id="11" name="">
             <a:extLst xmlns:a="http://schemas.openxmlformats.org/drawingml/2006/main">
               <a:ext uri="{FF2B5EF4-FFF2-40B4-BE49-F238E27FC236}">
-                <a16:creationId xmlns:a16="http://schemas.microsoft.com/office/drawing/2014/main" id="{77EF8FB3-F6D6-40C3-B9CC-E24F0AAE8ADF}"/>
+                <a16:creationId xmlns:a16="http://schemas.microsoft.com/office/drawing/2014/main" id="{BC3946FB-FB9D-4D82-A971-90B9113E0BF1}"/>
               </a:ext>
             </a:extLst>
           </p:cNvPr>
@@ -14673,7 +14673,7 @@
           <p:cNvPr id="12" name="">
             <a:extLst xmlns:a="http://schemas.openxmlformats.org/drawingml/2006/main">
               <a:ext uri="{FF2B5EF4-FFF2-40B4-BE49-F238E27FC236}">
-                <a16:creationId xmlns:a16="http://schemas.microsoft.com/office/drawing/2014/main" id="{55664202-7383-47BE-B8BF-2F530EBF49BD}"/>
+                <a16:creationId xmlns:a16="http://schemas.microsoft.com/office/drawing/2014/main" id="{8B0E3741-0FD3-4AE0-AE9C-5070534D465B}"/>
               </a:ext>
             </a:extLst>
           </p:cNvPr>
@@ -14723,7 +14723,7 @@
           <p:cNvPr id="13" name="">
             <a:extLst xmlns:a="http://schemas.openxmlformats.org/drawingml/2006/main">
               <a:ext uri="{FF2B5EF4-FFF2-40B4-BE49-F238E27FC236}">
-                <a16:creationId xmlns:a16="http://schemas.microsoft.com/office/drawing/2014/main" id="{FC02A5DE-7164-42D6-B38F-85290676651C}"/>
+                <a16:creationId xmlns:a16="http://schemas.microsoft.com/office/drawing/2014/main" id="{749F37A1-1139-4092-8AC9-554CC6459E3F}"/>
               </a:ext>
             </a:extLst>
           </p:cNvPr>
@@ -14756,7 +14756,7 @@
           <p:cNvPr id="14" name="">
             <a:extLst xmlns:a="http://schemas.openxmlformats.org/drawingml/2006/main">
               <a:ext uri="{FF2B5EF4-FFF2-40B4-BE49-F238E27FC236}">
-                <a16:creationId xmlns:a16="http://schemas.microsoft.com/office/drawing/2014/main" id="{A1739673-7297-4484-BA02-77FCEA399449}"/>
+                <a16:creationId xmlns:a16="http://schemas.microsoft.com/office/drawing/2014/main" id="{42B678A3-2037-4D78-AA87-FE1ACC25076E}"/>
               </a:ext>
             </a:extLst>
           </p:cNvPr>
@@ -14806,7 +14806,7 @@
           <p:cNvPr id="15" name="">
             <a:extLst xmlns:a="http://schemas.openxmlformats.org/drawingml/2006/main">
               <a:ext uri="{FF2B5EF4-FFF2-40B4-BE49-F238E27FC236}">
-                <a16:creationId xmlns:a16="http://schemas.microsoft.com/office/drawing/2014/main" id="{5A913859-3D94-4DBC-BE98-D56AA11B22D8}"/>
+                <a16:creationId xmlns:a16="http://schemas.microsoft.com/office/drawing/2014/main" id="{86ADE060-A666-458B-9FA3-F2D2536B628D}"/>
               </a:ext>
             </a:extLst>
           </p:cNvPr>
@@ -14856,7 +14856,7 @@
           <p:cNvPr id="16" name="">
             <a:extLst xmlns:a="http://schemas.openxmlformats.org/drawingml/2006/main">
               <a:ext uri="{FF2B5EF4-FFF2-40B4-BE49-F238E27FC236}">
-                <a16:creationId xmlns:a16="http://schemas.microsoft.com/office/drawing/2014/main" id="{F6604778-3578-4111-BCC4-8B5B74E9F499}"/>
+                <a16:creationId xmlns:a16="http://schemas.microsoft.com/office/drawing/2014/main" id="{1615E624-04BD-40E9-8335-66E6CC645604}"/>
               </a:ext>
             </a:extLst>
           </p:cNvPr>
@@ -14889,7 +14889,7 @@
           <p:cNvPr id="17" name="">
             <a:extLst xmlns:a="http://schemas.openxmlformats.org/drawingml/2006/main">
               <a:ext uri="{FF2B5EF4-FFF2-40B4-BE49-F238E27FC236}">
-                <a16:creationId xmlns:a16="http://schemas.microsoft.com/office/drawing/2014/main" id="{FE2385A4-C506-4F5D-8CD6-1B51CB6D5D1C}"/>
+                <a16:creationId xmlns:a16="http://schemas.microsoft.com/office/drawing/2014/main" id="{C317D04A-CF7B-4D0A-A235-2E724DC8D5B0}"/>
               </a:ext>
             </a:extLst>
           </p:cNvPr>
@@ -14939,7 +14939,7 @@
           <p:cNvPr id="18" name="">
             <a:extLst xmlns:a="http://schemas.openxmlformats.org/drawingml/2006/main">
               <a:ext uri="{FF2B5EF4-FFF2-40B4-BE49-F238E27FC236}">
-                <a16:creationId xmlns:a16="http://schemas.microsoft.com/office/drawing/2014/main" id="{56B3956B-18E1-4E06-927A-BCEAEFBDDB54}"/>
+                <a16:creationId xmlns:a16="http://schemas.microsoft.com/office/drawing/2014/main" id="{4866D58E-BF64-44C6-87FA-A2F3E6D0B1D4}"/>
               </a:ext>
             </a:extLst>
           </p:cNvPr>
@@ -14989,7 +14989,7 @@
           <p:cNvPr id="19" name="">
             <a:extLst xmlns:a="http://schemas.openxmlformats.org/drawingml/2006/main">
               <a:ext uri="{FF2B5EF4-FFF2-40B4-BE49-F238E27FC236}">
-                <a16:creationId xmlns:a16="http://schemas.microsoft.com/office/drawing/2014/main" id="{266BD6C8-CE2A-404A-831A-F0043886E72B}"/>
+                <a16:creationId xmlns:a16="http://schemas.microsoft.com/office/drawing/2014/main" id="{05AAE324-D02F-4006-B954-B62F65FE00D4}"/>
               </a:ext>
             </a:extLst>
           </p:cNvPr>
@@ -15039,7 +15039,7 @@
           <p:cNvPr id="20" name="">
             <a:extLst xmlns:a="http://schemas.openxmlformats.org/drawingml/2006/main">
               <a:ext uri="{FF2B5EF4-FFF2-40B4-BE49-F238E27FC236}">
-                <a16:creationId xmlns:a16="http://schemas.microsoft.com/office/drawing/2014/main" id="{36C28B79-60ED-450F-9839-9625D75E0358}"/>
+                <a16:creationId xmlns:a16="http://schemas.microsoft.com/office/drawing/2014/main" id="{6F8A0F48-DC6F-4339-9508-E6893C72C75C}"/>
               </a:ext>
             </a:extLst>
           </p:cNvPr>
@@ -15089,7 +15089,7 @@
           <p:cNvPr id="21" name="">
             <a:extLst xmlns:a="http://schemas.openxmlformats.org/drawingml/2006/main">
               <a:ext uri="{FF2B5EF4-FFF2-40B4-BE49-F238E27FC236}">
-                <a16:creationId xmlns:a16="http://schemas.microsoft.com/office/drawing/2014/main" id="{3AF68874-5963-4FBE-8E04-C1D34EED7F46}"/>
+                <a16:creationId xmlns:a16="http://schemas.microsoft.com/office/drawing/2014/main" id="{89E99EDF-AC14-4AF4-9851-37A41FAE3350}"/>
               </a:ext>
             </a:extLst>
           </p:cNvPr>
@@ -15139,7 +15139,7 @@
           <p:cNvPr id="22" name="">
             <a:extLst xmlns:a="http://schemas.openxmlformats.org/drawingml/2006/main">
               <a:ext uri="{FF2B5EF4-FFF2-40B4-BE49-F238E27FC236}">
-                <a16:creationId xmlns:a16="http://schemas.microsoft.com/office/drawing/2014/main" id="{BC40F9DB-E48E-41FB-B89E-2DB7C3886FC5}"/>
+                <a16:creationId xmlns:a16="http://schemas.microsoft.com/office/drawing/2014/main" id="{6E9462D3-CF35-4E91-B58F-503595FEA02A}"/>
               </a:ext>
             </a:extLst>
           </p:cNvPr>
@@ -15189,7 +15189,7 @@
           <p:cNvPr id="23" name="">
             <a:extLst xmlns:a="http://schemas.openxmlformats.org/drawingml/2006/main">
               <a:ext uri="{FF2B5EF4-FFF2-40B4-BE49-F238E27FC236}">
-                <a16:creationId xmlns:a16="http://schemas.microsoft.com/office/drawing/2014/main" id="{237226C5-CBFE-4179-972C-8F2E9C89E4D2}"/>
+                <a16:creationId xmlns:a16="http://schemas.microsoft.com/office/drawing/2014/main" id="{4FF59699-04B3-4587-946C-00FADCEDD4B3}"/>
               </a:ext>
             </a:extLst>
           </p:cNvPr>
@@ -15239,7 +15239,7 @@
           <p:cNvPr id="24" name="">
             <a:extLst xmlns:a="http://schemas.openxmlformats.org/drawingml/2006/main">
               <a:ext uri="{FF2B5EF4-FFF2-40B4-BE49-F238E27FC236}">
-                <a16:creationId xmlns:a16="http://schemas.microsoft.com/office/drawing/2014/main" id="{69BF8811-CA76-4CF8-A39C-205CE04F0649}"/>
+                <a16:creationId xmlns:a16="http://schemas.microsoft.com/office/drawing/2014/main" id="{B6A8A71F-B995-4F0D-A3EA-3B0179EE8F9A}"/>
               </a:ext>
             </a:extLst>
           </p:cNvPr>
@@ -15287,7 +15287,7 @@
     </p:spTree>
     <p:extLst>
       <p:ext uri="{BB962C8B-B14F-4D97-AF65-F5344CB8AC3E}">
-        <p14:creationId xmlns:p14="http://schemas.microsoft.com/office/powerpoint/2010/main" val="569098466"/>
+        <p14:creationId xmlns:p14="http://schemas.microsoft.com/office/powerpoint/2010/main" val="680356443"/>
       </p:ext>
     </p:extLst>
   </p:cSld>
@@ -15318,7 +15318,7 @@
           <p:cNvPr id="16" name="">
             <a:extLst xmlns:a="http://schemas.openxmlformats.org/drawingml/2006/main">
               <a:ext uri="{FF2B5EF4-FFF2-40B4-BE49-F238E27FC236}">
-                <a16:creationId xmlns:a16="http://schemas.microsoft.com/office/drawing/2014/main" id="{9BB89DF7-C862-412F-8B91-4CED2FAF57D4}"/>
+                <a16:creationId xmlns:a16="http://schemas.microsoft.com/office/drawing/2014/main" id="{BD3B9B8F-9178-460A-BE4D-3A2A30607F14}"/>
               </a:ext>
             </a:extLst>
           </p:cNvPr>
@@ -15351,7 +15351,7 @@
           <p:cNvPr id="2" name="">
             <a:extLst xmlns:a="http://schemas.openxmlformats.org/drawingml/2006/main">
               <a:ext uri="{FF2B5EF4-FFF2-40B4-BE49-F238E27FC236}">
-                <a16:creationId xmlns:a16="http://schemas.microsoft.com/office/drawing/2014/main" id="{DD1F0FF4-6182-4F4D-93B7-CB409E8E00B7}"/>
+                <a16:creationId xmlns:a16="http://schemas.microsoft.com/office/drawing/2014/main" id="{D52EEA9B-9F56-4B6F-87FA-DB9A92321EDF}"/>
               </a:ext>
             </a:extLst>
           </p:cNvPr>
@@ -15401,7 +15401,7 @@
           <p:cNvPr id="3" name="">
             <a:extLst xmlns:a="http://schemas.openxmlformats.org/drawingml/2006/main">
               <a:ext uri="{FF2B5EF4-FFF2-40B4-BE49-F238E27FC236}">
-                <a16:creationId xmlns:a16="http://schemas.microsoft.com/office/drawing/2014/main" id="{7BD49058-03B2-4247-9439-3DA32883FB0C}"/>
+                <a16:creationId xmlns:a16="http://schemas.microsoft.com/office/drawing/2014/main" id="{2E8C8194-6D66-467E-A150-542614B4F0C6}"/>
               </a:ext>
             </a:extLst>
           </p:cNvPr>
@@ -15434,7 +15434,7 @@
           <p:cNvPr id="4" name="">
             <a:extLst xmlns:a="http://schemas.openxmlformats.org/drawingml/2006/main">
               <a:ext uri="{FF2B5EF4-FFF2-40B4-BE49-F238E27FC236}">
-                <a16:creationId xmlns:a16="http://schemas.microsoft.com/office/drawing/2014/main" id="{41C2BDC5-22A7-419A-BCE7-847ADAEED69E}"/>
+                <a16:creationId xmlns:a16="http://schemas.microsoft.com/office/drawing/2014/main" id="{DC263C8E-E7D8-43A9-A20E-083A9CE42F43}"/>
               </a:ext>
             </a:extLst>
           </p:cNvPr>
@@ -15484,7 +15484,7 @@
           <p:cNvPr id="5" name="">
             <a:extLst xmlns:a="http://schemas.openxmlformats.org/drawingml/2006/main">
               <a:ext uri="{FF2B5EF4-FFF2-40B4-BE49-F238E27FC236}">
-                <a16:creationId xmlns:a16="http://schemas.microsoft.com/office/drawing/2014/main" id="{7772E865-DDE7-4416-A1EB-DBB5D79D9C8D}"/>
+                <a16:creationId xmlns:a16="http://schemas.microsoft.com/office/drawing/2014/main" id="{644B05EF-28C3-4C5F-8FFB-03230B36058E}"/>
               </a:ext>
             </a:extLst>
           </p:cNvPr>
@@ -15541,7 +15541,7 @@
         </p:xfrm>
         <a:graphic xmlns:a="http://schemas.openxmlformats.org/drawingml/2006/main">
           <a:graphicData uri="http://schemas.openxmlformats.org/drawingml/2006/chart">
-            <c:chart xmlns:r="http://schemas.openxmlformats.org/officeDocument/2006/relationships" xmlns:c="http://schemas.openxmlformats.org/drawingml/2006/chart" r:id="R348bd2e30229441a"/>
+            <c:chart xmlns:r="http://schemas.openxmlformats.org/officeDocument/2006/relationships" xmlns:c="http://schemas.openxmlformats.org/drawingml/2006/chart" r:id="R8f64f992cc68470e"/>
           </a:graphicData>
         </a:graphic>
       </p:graphicFrame>
@@ -15550,7 +15550,7 @@
           <p:cNvPr id="7" name="">
             <a:extLst xmlns:a="http://schemas.openxmlformats.org/drawingml/2006/main">
               <a:ext uri="{FF2B5EF4-FFF2-40B4-BE49-F238E27FC236}">
-                <a16:creationId xmlns:a16="http://schemas.microsoft.com/office/drawing/2014/main" id="{B86968A1-23E7-48BF-9635-F58EFE6EF8DB}"/>
+                <a16:creationId xmlns:a16="http://schemas.microsoft.com/office/drawing/2014/main" id="{A9AFCD73-8563-4BD6-AC47-DF3012D4ADAE}"/>
               </a:ext>
             </a:extLst>
           </p:cNvPr>
@@ -15600,7 +15600,7 @@
           <p:cNvPr id="8" name="">
             <a:extLst xmlns:a="http://schemas.openxmlformats.org/drawingml/2006/main">
               <a:ext uri="{FF2B5EF4-FFF2-40B4-BE49-F238E27FC236}">
-                <a16:creationId xmlns:a16="http://schemas.microsoft.com/office/drawing/2014/main" id="{0EDF3E0C-97CE-4E54-A846-BB86D6CBA524}"/>
+                <a16:creationId xmlns:a16="http://schemas.microsoft.com/office/drawing/2014/main" id="{C3890D2A-0901-4F21-AD46-68309378CD96}"/>
               </a:ext>
             </a:extLst>
           </p:cNvPr>
@@ -15650,7 +15650,7 @@
           <p:cNvPr id="9" name="">
             <a:extLst xmlns:a="http://schemas.openxmlformats.org/drawingml/2006/main">
               <a:ext uri="{FF2B5EF4-FFF2-40B4-BE49-F238E27FC236}">
-                <a16:creationId xmlns:a16="http://schemas.microsoft.com/office/drawing/2014/main" id="{63D9DA52-E7E5-4844-8567-6E1677745E13}"/>
+                <a16:creationId xmlns:a16="http://schemas.microsoft.com/office/drawing/2014/main" id="{49D9F831-C671-4FFB-80A6-0426F24136D3}"/>
               </a:ext>
             </a:extLst>
           </p:cNvPr>
@@ -15700,7 +15700,7 @@
           <p:cNvPr id="10" name="">
             <a:extLst xmlns:a="http://schemas.openxmlformats.org/drawingml/2006/main">
               <a:ext uri="{FF2B5EF4-FFF2-40B4-BE49-F238E27FC236}">
-                <a16:creationId xmlns:a16="http://schemas.microsoft.com/office/drawing/2014/main" id="{BBB1EB9E-0088-4B32-A915-F8DE9B08EDDD}"/>
+                <a16:creationId xmlns:a16="http://schemas.microsoft.com/office/drawing/2014/main" id="{FAD88B34-A3A0-45E0-8F06-7C4DF18B1A6A}"/>
               </a:ext>
             </a:extLst>
           </p:cNvPr>
@@ -15750,7 +15750,7 @@
           <p:cNvPr id="11" name="">
             <a:extLst xmlns:a="http://schemas.openxmlformats.org/drawingml/2006/main">
               <a:ext uri="{FF2B5EF4-FFF2-40B4-BE49-F238E27FC236}">
-                <a16:creationId xmlns:a16="http://schemas.microsoft.com/office/drawing/2014/main" id="{C1EF75E7-6801-4EAE-82CE-014EC6AA5BC7}"/>
+                <a16:creationId xmlns:a16="http://schemas.microsoft.com/office/drawing/2014/main" id="{0413DE1E-CF0A-4FB5-8F26-C65EE37D61F3}"/>
               </a:ext>
             </a:extLst>
           </p:cNvPr>
@@ -15800,7 +15800,7 @@
           <p:cNvPr id="12" name="">
             <a:extLst xmlns:a="http://schemas.openxmlformats.org/drawingml/2006/main">
               <a:ext uri="{FF2B5EF4-FFF2-40B4-BE49-F238E27FC236}">
-                <a16:creationId xmlns:a16="http://schemas.microsoft.com/office/drawing/2014/main" id="{4F913ECA-7969-4180-B608-33F2BCC65E5F}"/>
+                <a16:creationId xmlns:a16="http://schemas.microsoft.com/office/drawing/2014/main" id="{2DDDCF6E-06F8-4956-B3C5-643D1E617002}"/>
               </a:ext>
             </a:extLst>
           </p:cNvPr>
@@ -15850,7 +15850,7 @@
           <p:cNvPr id="13" name="">
             <a:extLst xmlns:a="http://schemas.openxmlformats.org/drawingml/2006/main">
               <a:ext uri="{FF2B5EF4-FFF2-40B4-BE49-F238E27FC236}">
-                <a16:creationId xmlns:a16="http://schemas.microsoft.com/office/drawing/2014/main" id="{97E3687A-4D88-44CE-8E01-7BCD9ED71B1D}"/>
+                <a16:creationId xmlns:a16="http://schemas.microsoft.com/office/drawing/2014/main" id="{ADB73CF0-7AAE-46D7-9712-ABD487D6E939}"/>
               </a:ext>
             </a:extLst>
           </p:cNvPr>
@@ -15890,7 +15890,7 @@
                   <a:srgbClr val="111111"/>
                 </a:solidFill>
               </a:rPr>
-              <a:t>PPA amortization worsens reported EPS but does not explain all dilution.</a:t>
+              <a:t>PPA amortization worsens EPS including PPA but does not explain all dilution.</a:t>
             </a:r>
           </a:p>
         </p:txBody>
@@ -15900,7 +15900,7 @@
           <p:cNvPr id="14" name="">
             <a:extLst xmlns:a="http://schemas.openxmlformats.org/drawingml/2006/main">
               <a:ext uri="{FF2B5EF4-FFF2-40B4-BE49-F238E27FC236}">
-                <a16:creationId xmlns:a16="http://schemas.microsoft.com/office/drawing/2014/main" id="{CD39402A-3B5E-4CCC-A8AE-9139CF4A7B84}"/>
+                <a16:creationId xmlns:a16="http://schemas.microsoft.com/office/drawing/2014/main" id="{0B2A8B70-5B7B-45D9-A044-8BB48502A71E}"/>
               </a:ext>
             </a:extLst>
           </p:cNvPr>
@@ -15950,7 +15950,7 @@
           <p:cNvPr id="15" name="">
             <a:extLst xmlns:a="http://schemas.openxmlformats.org/drawingml/2006/main">
               <a:ext uri="{FF2B5EF4-FFF2-40B4-BE49-F238E27FC236}">
-                <a16:creationId xmlns:a16="http://schemas.microsoft.com/office/drawing/2014/main" id="{013275CB-6C2D-4AFD-9FCE-C4AD3E50C846}"/>
+                <a16:creationId xmlns:a16="http://schemas.microsoft.com/office/drawing/2014/main" id="{BB662713-40BB-42E7-8C3C-C792E366982C}"/>
               </a:ext>
             </a:extLst>
           </p:cNvPr>
@@ -15998,7 +15998,7 @@
     </p:spTree>
     <p:extLst>
       <p:ext uri="{BB962C8B-B14F-4D97-AF65-F5344CB8AC3E}">
-        <p14:creationId xmlns:p14="http://schemas.microsoft.com/office/powerpoint/2010/main" val="1614834555"/>
+        <p14:creationId xmlns:p14="http://schemas.microsoft.com/office/powerpoint/2010/main" val="2118210784"/>
       </p:ext>
     </p:extLst>
   </p:cSld>

</xml_diff>